<commit_message>
Week 5 Lecture Material
</commit_message>
<xml_diff>
--- a/10-152-117_Python_Programming/Slide_Decks/W0ND0N_Lecture_Slides.pptx
+++ b/10-152-117_Python_Programming/Slide_Decks/W0ND0N_Lecture_Slides.pptx
@@ -17,13 +17,13 @@
     <p:sldId id="260" r:id="rId5"/>
     <p:sldId id="364" r:id="rId6"/>
     <p:sldId id="322" r:id="rId7"/>
-    <p:sldId id="323" r:id="rId8"/>
+    <p:sldId id="488" r:id="rId8"/>
     <p:sldId id="269" r:id="rId9"/>
     <p:sldId id="376" r:id="rId10"/>
     <p:sldId id="377" r:id="rId11"/>
     <p:sldId id="487" r:id="rId12"/>
-    <p:sldId id="378" r:id="rId13"/>
-    <p:sldId id="418" r:id="rId14"/>
+    <p:sldId id="418" r:id="rId13"/>
+    <p:sldId id="378" r:id="rId14"/>
     <p:sldId id="369" r:id="rId15"/>
     <p:sldId id="307" r:id="rId16"/>
     <p:sldId id="309" r:id="rId17"/>
@@ -938,7 +938,7 @@
 <dgm:dataModel xmlns:dgm="http://schemas.openxmlformats.org/drawingml/2006/diagram" xmlns:a="http://schemas.openxmlformats.org/drawingml/2006/main">
   <dgm:ptLst>
     <dgm:pt modelId="{A8972B69-4B4F-436A-B547-1FADC4FB29B4}" type="doc">
-      <dgm:prSet loTypeId="urn:microsoft.com/office/officeart/2005/8/layout/vList2" loCatId="list" qsTypeId="urn:microsoft.com/office/officeart/2005/8/quickstyle/simple4" qsCatId="simple" csTypeId="urn:microsoft.com/office/officeart/2005/8/colors/colorful2" csCatId="colorful"/>
+      <dgm:prSet loTypeId="urn:microsoft.com/office/officeart/2005/8/layout/process4" loCatId="process" qsTypeId="urn:microsoft.com/office/officeart/2005/8/quickstyle/simple4" qsCatId="simple" csTypeId="urn:microsoft.com/office/officeart/2005/8/colors/colorful2" csCatId="colorful" phldr="1"/>
       <dgm:spPr/>
       <dgm:t>
         <a:bodyPr/>
@@ -956,11 +956,36 @@
         <a:lstStyle/>
         <a:p>
           <a:r>
-            <a:rPr lang="en-US"/>
-            <a:t>compare two approaches</a:t>
+            <a:rPr lang="en-US" dirty="0"/>
+            <a:t>Working baseline -&gt;</a:t>
+          </a:r>
+          <a:br>
+            <a:rPr lang="en-US" dirty="0"/>
+          </a:br>
+          <a:r>
+            <a:rPr lang="en-US" dirty="0"/>
+            <a:t>compare structure -&gt;</a:t>
+          </a:r>
+          <a:br>
+            <a:rPr lang="en-US" dirty="0"/>
+          </a:br>
+          <a:r>
+            <a:rPr lang="en-US" dirty="0"/>
+            <a:t>revise one meaningful thing -&gt; explain the improvement.</a:t>
           </a:r>
         </a:p>
       </dgm:t>
+      <dgm:extLst>
+        <a:ext uri="{E40237B7-FDA0-4F09-8148-C483321AD2D9}">
+          <dgm14:cNvPr xmlns:dgm14="http://schemas.microsoft.com/office/drawing/2010/diagram" id="0" name="">
+            <a:extLst>
+              <a:ext uri="{C183D7F6-B498-43B3-948B-1728B52AA6E4}">
+                <adec:decorative xmlns:adec="http://schemas.microsoft.com/office/drawing/2017/decorative" val="1"/>
+              </a:ext>
+            </a:extLst>
+          </dgm14:cNvPr>
+        </a:ext>
+      </dgm:extLst>
     </dgm:pt>
     <dgm:pt modelId="{4FAABBF4-AB55-44FE-B6F0-B4BF829D004F}" type="parTrans" cxnId="{7F9DA8A4-8191-4121-8DA1-F0552EB3E440}">
       <dgm:prSet/>
@@ -984,7 +1009,7 @@
         </a:p>
       </dgm:t>
     </dgm:pt>
-    <dgm:pt modelId="{96935FEB-D109-4185-8EE9-E323C3602104}">
+    <dgm:pt modelId="{EB5121E5-32EC-4CC1-8D66-D95323571777}">
       <dgm:prSet/>
       <dgm:spPr/>
       <dgm:t>
@@ -992,13 +1017,24 @@
         <a:lstStyle/>
         <a:p>
           <a:r>
-            <a:rPr lang="en-US"/>
-            <a:t>collect timing evidence</a:t>
+            <a:rPr lang="en-US" dirty="0"/>
+            <a:t>A useful revision should make the program:</a:t>
           </a:r>
         </a:p>
       </dgm:t>
+      <dgm:extLst>
+        <a:ext uri="{E40237B7-FDA0-4F09-8148-C483321AD2D9}">
+          <dgm14:cNvPr xmlns:dgm14="http://schemas.microsoft.com/office/drawing/2010/diagram" id="0" name="">
+            <a:extLst>
+              <a:ext uri="{C183D7F6-B498-43B3-948B-1728B52AA6E4}">
+                <adec:decorative xmlns:adec="http://schemas.microsoft.com/office/drawing/2017/decorative" val="1"/>
+              </a:ext>
+            </a:extLst>
+          </dgm14:cNvPr>
+        </a:ext>
+      </dgm:extLst>
     </dgm:pt>
-    <dgm:pt modelId="{6DF3CCD5-B5C9-4831-9066-7DBDEBE0525B}" type="parTrans" cxnId="{0DDA5CB6-9147-4ADF-A2D0-E56811CCA430}">
+    <dgm:pt modelId="{688F2547-1224-41BA-B5A3-11ACD36BDE10}" type="parTrans" cxnId="{6128F5AF-C1A9-41F0-B2F1-8F28816F04E7}">
       <dgm:prSet/>
       <dgm:spPr/>
       <dgm:t>
@@ -1009,7 +1045,7 @@
         </a:p>
       </dgm:t>
     </dgm:pt>
-    <dgm:pt modelId="{415E7A3D-A483-4CB9-A3DB-D79D75E8607A}" type="sibTrans" cxnId="{0DDA5CB6-9147-4ADF-A2D0-E56811CCA430}">
+    <dgm:pt modelId="{D6AD86F4-A6C8-4FE0-AF15-A11786D5D5A7}" type="sibTrans" cxnId="{6128F5AF-C1A9-41F0-B2F1-8F28816F04E7}">
       <dgm:prSet/>
       <dgm:spPr/>
       <dgm:t>
@@ -1020,7 +1056,7 @@
         </a:p>
       </dgm:t>
     </dgm:pt>
-    <dgm:pt modelId="{41719C92-45D5-47D0-862D-1113EE6CB002}">
+    <dgm:pt modelId="{9182D038-504A-4BAB-926D-C43E3569DBBF}">
       <dgm:prSet/>
       <dgm:spPr/>
       <dgm:t>
@@ -1028,13 +1064,13 @@
         <a:lstStyle/>
         <a:p>
           <a:r>
-            <a:rPr lang="en-US"/>
-            <a:t>describe growth cautiously</a:t>
+            <a:rPr lang="en-US" dirty="0"/>
+            <a:t>clearer</a:t>
           </a:r>
         </a:p>
       </dgm:t>
     </dgm:pt>
-    <dgm:pt modelId="{F821EB8B-B4FE-47E8-A0AC-2E1BB8667246}" type="parTrans" cxnId="{0287DCE1-186E-457F-9F74-863BDD6200E5}">
+    <dgm:pt modelId="{00F85236-5344-4DED-89C4-7F145D94A221}" type="parTrans" cxnId="{C670E53E-9704-4E9D-9DD5-43CBCDDB40CF}">
       <dgm:prSet/>
       <dgm:spPr/>
       <dgm:t>
@@ -1045,7 +1081,7 @@
         </a:p>
       </dgm:t>
     </dgm:pt>
-    <dgm:pt modelId="{F4A4A704-B603-4EC7-A6B1-941D75CEC658}" type="sibTrans" cxnId="{0287DCE1-186E-457F-9F74-863BDD6200E5}">
+    <dgm:pt modelId="{AF0FFC48-338E-4ACC-9B88-42F7B229AF6E}" type="sibTrans" cxnId="{C670E53E-9704-4E9D-9DD5-43CBCDDB40CF}">
       <dgm:prSet/>
       <dgm:spPr/>
       <dgm:t>
@@ -1056,7 +1092,7 @@
         </a:p>
       </dgm:t>
     </dgm:pt>
-    <dgm:pt modelId="{55671D6C-E249-4CFD-8437-8240375FBD60}">
+    <dgm:pt modelId="{803D0F37-C69D-433A-8B5B-D4CF3107BCE9}">
       <dgm:prSet/>
       <dgm:spPr/>
       <dgm:t>
@@ -1064,13 +1100,13 @@
         <a:lstStyle/>
         <a:p>
           <a:r>
-            <a:rPr lang="en-US"/>
-            <a:t>use basic Big-O vocabulary</a:t>
+            <a:rPr lang="en-US" dirty="0"/>
+            <a:t>easier to test</a:t>
           </a:r>
         </a:p>
       </dgm:t>
     </dgm:pt>
-    <dgm:pt modelId="{52A2D6EE-1D41-4E91-B8BB-D0D496786FA7}" type="parTrans" cxnId="{2EDB6E80-F13E-4D7C-8D0B-7CC664220615}">
+    <dgm:pt modelId="{0F8742D7-FE16-4859-8C1B-1BE78247EC74}" type="parTrans" cxnId="{96BD682A-FC68-4A7C-9512-924B325842BF}">
       <dgm:prSet/>
       <dgm:spPr/>
       <dgm:t>
@@ -1081,7 +1117,7 @@
         </a:p>
       </dgm:t>
     </dgm:pt>
-    <dgm:pt modelId="{E4C16C4D-0335-44B5-8F0C-8D1112AA08C1}" type="sibTrans" cxnId="{2EDB6E80-F13E-4D7C-8D0B-7CC664220615}">
+    <dgm:pt modelId="{0E35261A-B537-4AFB-863E-A615EE915685}" type="sibTrans" cxnId="{96BD682A-FC68-4A7C-9512-924B325842BF}">
       <dgm:prSet/>
       <dgm:spPr/>
       <dgm:t>
@@ -1092,7 +1128,7 @@
         </a:p>
       </dgm:t>
     </dgm:pt>
-    <dgm:pt modelId="{BDB4EDFC-503D-452F-A66C-73D4CE737F54}">
+    <dgm:pt modelId="{E7728A9D-D3DD-4591-9C7C-7E316C5C312A}">
       <dgm:prSet/>
       <dgm:spPr/>
       <dgm:t>
@@ -1100,13 +1136,13 @@
         <a:lstStyle/>
         <a:p>
           <a:r>
-            <a:rPr lang="en-US"/>
-            <a:t>identify a limitation of your evidence</a:t>
+            <a:rPr lang="en-US" dirty="0"/>
+            <a:t>easier to change</a:t>
           </a:r>
         </a:p>
       </dgm:t>
     </dgm:pt>
-    <dgm:pt modelId="{CF37DD21-1A1B-4AA0-A79A-17692B432E00}" type="parTrans" cxnId="{B19E6DF9-C0E2-4872-A269-F5BC6BD8F9E1}">
+    <dgm:pt modelId="{BFC6AE8E-AD4A-4D3E-8207-F17AF33DBF15}" type="parTrans" cxnId="{65A72186-C2FC-4687-92E8-A27D6DD132EC}">
       <dgm:prSet/>
       <dgm:spPr/>
       <dgm:t>
@@ -1117,7 +1153,7 @@
         </a:p>
       </dgm:t>
     </dgm:pt>
-    <dgm:pt modelId="{654411A5-B8B9-45FE-A6E9-1A0DB1FE3570}" type="sibTrans" cxnId="{B19E6DF9-C0E2-4872-A269-F5BC6BD8F9E1}">
+    <dgm:pt modelId="{A0B2B5BB-C1F7-46A1-94E8-3258A056C71B}" type="sibTrans" cxnId="{65A72186-C2FC-4687-92E8-A27D6DD132EC}">
       <dgm:prSet/>
       <dgm:spPr/>
       <dgm:t>
@@ -1128,98 +1164,139 @@
         </a:p>
       </dgm:t>
     </dgm:pt>
-    <dgm:pt modelId="{C74AEAA8-95AA-4DD2-B5BF-AF2613DDA678}" type="pres">
-      <dgm:prSet presAssocID="{A8972B69-4B4F-436A-B547-1FADC4FB29B4}" presName="linear" presStyleCnt="0">
+    <dgm:pt modelId="{EFA31A2A-5CD7-4982-8FD7-0A79E8DF64F4}">
+      <dgm:prSet/>
+      <dgm:spPr/>
+      <dgm:t>
+        <a:bodyPr/>
+        <a:lstStyle/>
+        <a:p>
+          <a:r>
+            <a:rPr lang="en-US" dirty="0"/>
+            <a:t>easier to explain</a:t>
+          </a:r>
+        </a:p>
+      </dgm:t>
+    </dgm:pt>
+    <dgm:pt modelId="{607DAFC8-6764-4FFC-8726-E6F514E61ACC}" type="parTrans" cxnId="{AD071327-7821-4960-BDDB-E10EFF1F1E09}">
+      <dgm:prSet/>
+      <dgm:spPr/>
+      <dgm:t>
+        <a:bodyPr/>
+        <a:lstStyle/>
+        <a:p>
+          <a:endParaRPr lang="en-US"/>
+        </a:p>
+      </dgm:t>
+    </dgm:pt>
+    <dgm:pt modelId="{74496212-F00F-40A5-91D1-4E6C3AEF82E9}" type="sibTrans" cxnId="{AD071327-7821-4960-BDDB-E10EFF1F1E09}">
+      <dgm:prSet/>
+      <dgm:spPr/>
+      <dgm:t>
+        <a:bodyPr/>
+        <a:lstStyle/>
+        <a:p>
+          <a:endParaRPr lang="en-US"/>
+        </a:p>
+      </dgm:t>
+    </dgm:pt>
+    <dgm:pt modelId="{C02D4931-3D53-44B6-8786-4F33D4438E16}" type="pres">
+      <dgm:prSet presAssocID="{A8972B69-4B4F-436A-B547-1FADC4FB29B4}" presName="Name0" presStyleCnt="0">
         <dgm:presLayoutVars>
+          <dgm:dir/>
           <dgm:animLvl val="lvl"/>
           <dgm:resizeHandles val="exact"/>
         </dgm:presLayoutVars>
       </dgm:prSet>
       <dgm:spPr/>
     </dgm:pt>
-    <dgm:pt modelId="{C717DEE2-2529-4048-A027-0347422F7B4B}" type="pres">
-      <dgm:prSet presAssocID="{A75A4D4B-BFE9-4B6F-9A81-9F9C96F5DA38}" presName="parentText" presStyleLbl="node1" presStyleIdx="0" presStyleCnt="5">
+    <dgm:pt modelId="{2F9D52CB-4845-4677-B495-47244B0A6919}" type="pres">
+      <dgm:prSet presAssocID="{EB5121E5-32EC-4CC1-8D66-D95323571777}" presName="boxAndChildren" presStyleCnt="0"/>
+      <dgm:spPr/>
+    </dgm:pt>
+    <dgm:pt modelId="{F94D21B4-717D-44F3-A5A2-7786D04B0D36}" type="pres">
+      <dgm:prSet presAssocID="{EB5121E5-32EC-4CC1-8D66-D95323571777}" presName="parentTextBox" presStyleLbl="node1" presStyleIdx="0" presStyleCnt="2"/>
+      <dgm:spPr/>
+    </dgm:pt>
+    <dgm:pt modelId="{461B57AD-775D-46BC-AF21-BF741DE08030}" type="pres">
+      <dgm:prSet presAssocID="{EB5121E5-32EC-4CC1-8D66-D95323571777}" presName="entireBox" presStyleLbl="node1" presStyleIdx="0" presStyleCnt="2"/>
+      <dgm:spPr/>
+    </dgm:pt>
+    <dgm:pt modelId="{83951E30-0CAF-40F5-A939-932BE4AB7938}" type="pres">
+      <dgm:prSet presAssocID="{EB5121E5-32EC-4CC1-8D66-D95323571777}" presName="descendantBox" presStyleCnt="0"/>
+      <dgm:spPr/>
+    </dgm:pt>
+    <dgm:pt modelId="{DFEB7707-965B-4E91-8967-EA2DDFBF218E}" type="pres">
+      <dgm:prSet presAssocID="{9182D038-504A-4BAB-926D-C43E3569DBBF}" presName="childTextBox" presStyleLbl="fgAccFollowNode1" presStyleIdx="0" presStyleCnt="4">
         <dgm:presLayoutVars>
-          <dgm:chMax val="0"/>
           <dgm:bulletEnabled val="1"/>
         </dgm:presLayoutVars>
       </dgm:prSet>
       <dgm:spPr/>
     </dgm:pt>
-    <dgm:pt modelId="{4287A08D-B1A3-4BC4-BB02-712CE914270A}" type="pres">
-      <dgm:prSet presAssocID="{7E1354BB-EC61-4A45-99C9-75C6202CC56A}" presName="spacer" presStyleCnt="0"/>
-      <dgm:spPr/>
-    </dgm:pt>
-    <dgm:pt modelId="{953729D8-D97F-44F2-81C8-913FF1732DF0}" type="pres">
-      <dgm:prSet presAssocID="{96935FEB-D109-4185-8EE9-E323C3602104}" presName="parentText" presStyleLbl="node1" presStyleIdx="1" presStyleCnt="5">
+    <dgm:pt modelId="{B73B748A-13E7-4DEF-98B7-3EA10A235998}" type="pres">
+      <dgm:prSet presAssocID="{803D0F37-C69D-433A-8B5B-D4CF3107BCE9}" presName="childTextBox" presStyleLbl="fgAccFollowNode1" presStyleIdx="1" presStyleCnt="4">
         <dgm:presLayoutVars>
-          <dgm:chMax val="0"/>
           <dgm:bulletEnabled val="1"/>
         </dgm:presLayoutVars>
       </dgm:prSet>
       <dgm:spPr/>
     </dgm:pt>
-    <dgm:pt modelId="{CFA41472-2BE5-47B1-9CB3-237F433878BD}" type="pres">
-      <dgm:prSet presAssocID="{415E7A3D-A483-4CB9-A3DB-D79D75E8607A}" presName="spacer" presStyleCnt="0"/>
-      <dgm:spPr/>
-    </dgm:pt>
-    <dgm:pt modelId="{A8D91054-8DD9-448A-904B-04704F91BE5B}" type="pres">
-      <dgm:prSet presAssocID="{41719C92-45D5-47D0-862D-1113EE6CB002}" presName="parentText" presStyleLbl="node1" presStyleIdx="2" presStyleCnt="5">
+    <dgm:pt modelId="{AF879534-F1EC-4012-93E0-D6A87B0DF1D2}" type="pres">
+      <dgm:prSet presAssocID="{E7728A9D-D3DD-4591-9C7C-7E316C5C312A}" presName="childTextBox" presStyleLbl="fgAccFollowNode1" presStyleIdx="2" presStyleCnt="4">
         <dgm:presLayoutVars>
-          <dgm:chMax val="0"/>
           <dgm:bulletEnabled val="1"/>
         </dgm:presLayoutVars>
       </dgm:prSet>
       <dgm:spPr/>
     </dgm:pt>
-    <dgm:pt modelId="{2F6E42A2-4884-4DE6-9E60-C6274C59628F}" type="pres">
-      <dgm:prSet presAssocID="{F4A4A704-B603-4EC7-A6B1-941D75CEC658}" presName="spacer" presStyleCnt="0"/>
-      <dgm:spPr/>
-    </dgm:pt>
-    <dgm:pt modelId="{757879D0-74B4-423F-8DF0-7031701AE794}" type="pres">
-      <dgm:prSet presAssocID="{55671D6C-E249-4CFD-8437-8240375FBD60}" presName="parentText" presStyleLbl="node1" presStyleIdx="3" presStyleCnt="5">
+    <dgm:pt modelId="{0F565987-2C71-4DCF-A1C1-E0601B2C4C10}" type="pres">
+      <dgm:prSet presAssocID="{EFA31A2A-5CD7-4982-8FD7-0A79E8DF64F4}" presName="childTextBox" presStyleLbl="fgAccFollowNode1" presStyleIdx="3" presStyleCnt="4">
         <dgm:presLayoutVars>
-          <dgm:chMax val="0"/>
           <dgm:bulletEnabled val="1"/>
         </dgm:presLayoutVars>
       </dgm:prSet>
       <dgm:spPr/>
     </dgm:pt>
-    <dgm:pt modelId="{B1B62F95-136D-4EA2-B1D2-CCDC609FA9EF}" type="pres">
-      <dgm:prSet presAssocID="{E4C16C4D-0335-44B5-8F0C-8D1112AA08C1}" presName="spacer" presStyleCnt="0"/>
+    <dgm:pt modelId="{9D5C837F-8017-4AB9-8994-F8CB0FDCE4BB}" type="pres">
+      <dgm:prSet presAssocID="{7E1354BB-EC61-4A45-99C9-75C6202CC56A}" presName="sp" presStyleCnt="0"/>
       <dgm:spPr/>
     </dgm:pt>
-    <dgm:pt modelId="{2E76E2E3-35EA-48C7-A45C-F0395CE090B2}" type="pres">
-      <dgm:prSet presAssocID="{BDB4EDFC-503D-452F-A66C-73D4CE737F54}" presName="parentText" presStyleLbl="node1" presStyleIdx="4" presStyleCnt="5">
-        <dgm:presLayoutVars>
-          <dgm:chMax val="0"/>
-          <dgm:bulletEnabled val="1"/>
-        </dgm:presLayoutVars>
-      </dgm:prSet>
+    <dgm:pt modelId="{8A5E0D36-7A12-4198-A6F1-EA719691EE02}" type="pres">
+      <dgm:prSet presAssocID="{A75A4D4B-BFE9-4B6F-9A81-9F9C96F5DA38}" presName="arrowAndChildren" presStyleCnt="0"/>
+      <dgm:spPr/>
+    </dgm:pt>
+    <dgm:pt modelId="{882C4059-4D1A-489A-A4F8-99823542DCD9}" type="pres">
+      <dgm:prSet presAssocID="{A75A4D4B-BFE9-4B6F-9A81-9F9C96F5DA38}" presName="parentTextArrow" presStyleLbl="node1" presStyleIdx="1" presStyleCnt="2"/>
       <dgm:spPr/>
     </dgm:pt>
   </dgm:ptLst>
   <dgm:cxnLst>
-    <dgm:cxn modelId="{CA366F3D-BA56-4F02-96A4-ED9F01BBCA6F}" type="presOf" srcId="{BDB4EDFC-503D-452F-A66C-73D4CE737F54}" destId="{2E76E2E3-35EA-48C7-A45C-F0395CE090B2}" srcOrd="0" destOrd="0" presId="urn:microsoft.com/office/officeart/2005/8/layout/vList2"/>
-    <dgm:cxn modelId="{179BE43D-81D3-4FA7-81A7-787E007871DA}" type="presOf" srcId="{96935FEB-D109-4185-8EE9-E323C3602104}" destId="{953729D8-D97F-44F2-81C8-913FF1732DF0}" srcOrd="0" destOrd="0" presId="urn:microsoft.com/office/officeart/2005/8/layout/vList2"/>
-    <dgm:cxn modelId="{BB3A044D-0DD2-4AA1-8EE8-A3585DAF10B1}" type="presOf" srcId="{55671D6C-E249-4CFD-8437-8240375FBD60}" destId="{757879D0-74B4-423F-8DF0-7031701AE794}" srcOrd="0" destOrd="0" presId="urn:microsoft.com/office/officeart/2005/8/layout/vList2"/>
-    <dgm:cxn modelId="{2EDB6E80-F13E-4D7C-8D0B-7CC664220615}" srcId="{A8972B69-4B4F-436A-B547-1FADC4FB29B4}" destId="{55671D6C-E249-4CFD-8437-8240375FBD60}" srcOrd="3" destOrd="0" parTransId="{52A2D6EE-1D41-4E91-B8BB-D0D496786FA7}" sibTransId="{E4C16C4D-0335-44B5-8F0C-8D1112AA08C1}"/>
+    <dgm:cxn modelId="{6C177617-F56F-4B49-AFF7-5A0268F91B6B}" type="presOf" srcId="{EFA31A2A-5CD7-4982-8FD7-0A79E8DF64F4}" destId="{0F565987-2C71-4DCF-A1C1-E0601B2C4C10}" srcOrd="0" destOrd="0" presId="urn:microsoft.com/office/officeart/2005/8/layout/process4"/>
+    <dgm:cxn modelId="{69FB5222-4348-4978-B408-A352A515FB8C}" type="presOf" srcId="{A75A4D4B-BFE9-4B6F-9A81-9F9C96F5DA38}" destId="{882C4059-4D1A-489A-A4F8-99823542DCD9}" srcOrd="0" destOrd="0" presId="urn:microsoft.com/office/officeart/2005/8/layout/process4"/>
+    <dgm:cxn modelId="{AD071327-7821-4960-BDDB-E10EFF1F1E09}" srcId="{EB5121E5-32EC-4CC1-8D66-D95323571777}" destId="{EFA31A2A-5CD7-4982-8FD7-0A79E8DF64F4}" srcOrd="3" destOrd="0" parTransId="{607DAFC8-6764-4FFC-8726-E6F514E61ACC}" sibTransId="{74496212-F00F-40A5-91D1-4E6C3AEF82E9}"/>
+    <dgm:cxn modelId="{96BD682A-FC68-4A7C-9512-924B325842BF}" srcId="{EB5121E5-32EC-4CC1-8D66-D95323571777}" destId="{803D0F37-C69D-433A-8B5B-D4CF3107BCE9}" srcOrd="1" destOrd="0" parTransId="{0F8742D7-FE16-4859-8C1B-1BE78247EC74}" sibTransId="{0E35261A-B537-4AFB-863E-A615EE915685}"/>
+    <dgm:cxn modelId="{C670E53E-9704-4E9D-9DD5-43CBCDDB40CF}" srcId="{EB5121E5-32EC-4CC1-8D66-D95323571777}" destId="{9182D038-504A-4BAB-926D-C43E3569DBBF}" srcOrd="0" destOrd="0" parTransId="{00F85236-5344-4DED-89C4-7F145D94A221}" sibTransId="{AF0FFC48-338E-4ACC-9B88-42F7B229AF6E}"/>
+    <dgm:cxn modelId="{65304746-C94F-4A87-836B-B25C4460EDFE}" type="presOf" srcId="{A8972B69-4B4F-436A-B547-1FADC4FB29B4}" destId="{C02D4931-3D53-44B6-8786-4F33D4438E16}" srcOrd="0" destOrd="0" presId="urn:microsoft.com/office/officeart/2005/8/layout/process4"/>
+    <dgm:cxn modelId="{86FA586D-A309-4F89-BEBC-8E25BE20F502}" type="presOf" srcId="{E7728A9D-D3DD-4591-9C7C-7E316C5C312A}" destId="{AF879534-F1EC-4012-93E0-D6A87B0DF1D2}" srcOrd="0" destOrd="0" presId="urn:microsoft.com/office/officeart/2005/8/layout/process4"/>
+    <dgm:cxn modelId="{65A72186-C2FC-4687-92E8-A27D6DD132EC}" srcId="{EB5121E5-32EC-4CC1-8D66-D95323571777}" destId="{E7728A9D-D3DD-4591-9C7C-7E316C5C312A}" srcOrd="2" destOrd="0" parTransId="{BFC6AE8E-AD4A-4D3E-8207-F17AF33DBF15}" sibTransId="{A0B2B5BB-C1F7-46A1-94E8-3258A056C71B}"/>
     <dgm:cxn modelId="{7F9DA8A4-8191-4121-8DA1-F0552EB3E440}" srcId="{A8972B69-4B4F-436A-B547-1FADC4FB29B4}" destId="{A75A4D4B-BFE9-4B6F-9A81-9F9C96F5DA38}" srcOrd="0" destOrd="0" parTransId="{4FAABBF4-AB55-44FE-B6F0-B4BF829D004F}" sibTransId="{7E1354BB-EC61-4A45-99C9-75C6202CC56A}"/>
-    <dgm:cxn modelId="{F3DDD4B0-98F6-48B6-ACA5-ADB06939BE37}" type="presOf" srcId="{A8972B69-4B4F-436A-B547-1FADC4FB29B4}" destId="{C74AEAA8-95AA-4DD2-B5BF-AF2613DDA678}" srcOrd="0" destOrd="0" presId="urn:microsoft.com/office/officeart/2005/8/layout/vList2"/>
-    <dgm:cxn modelId="{0DDA5CB6-9147-4ADF-A2D0-E56811CCA430}" srcId="{A8972B69-4B4F-436A-B547-1FADC4FB29B4}" destId="{96935FEB-D109-4185-8EE9-E323C3602104}" srcOrd="1" destOrd="0" parTransId="{6DF3CCD5-B5C9-4831-9066-7DBDEBE0525B}" sibTransId="{415E7A3D-A483-4CB9-A3DB-D79D75E8607A}"/>
-    <dgm:cxn modelId="{414326CC-859F-45A0-BFF5-899BC45891B2}" type="presOf" srcId="{A75A4D4B-BFE9-4B6F-9A81-9F9C96F5DA38}" destId="{C717DEE2-2529-4048-A027-0347422F7B4B}" srcOrd="0" destOrd="0" presId="urn:microsoft.com/office/officeart/2005/8/layout/vList2"/>
-    <dgm:cxn modelId="{0287DCE1-186E-457F-9F74-863BDD6200E5}" srcId="{A8972B69-4B4F-436A-B547-1FADC4FB29B4}" destId="{41719C92-45D5-47D0-862D-1113EE6CB002}" srcOrd="2" destOrd="0" parTransId="{F821EB8B-B4FE-47E8-A0AC-2E1BB8667246}" sibTransId="{F4A4A704-B603-4EC7-A6B1-941D75CEC658}"/>
-    <dgm:cxn modelId="{B19E6DF9-C0E2-4872-A269-F5BC6BD8F9E1}" srcId="{A8972B69-4B4F-436A-B547-1FADC4FB29B4}" destId="{BDB4EDFC-503D-452F-A66C-73D4CE737F54}" srcOrd="4" destOrd="0" parTransId="{CF37DD21-1A1B-4AA0-A79A-17692B432E00}" sibTransId="{654411A5-B8B9-45FE-A6E9-1A0DB1FE3570}"/>
-    <dgm:cxn modelId="{BB78F2FA-3401-4393-97FB-D0AEF2460779}" type="presOf" srcId="{41719C92-45D5-47D0-862D-1113EE6CB002}" destId="{A8D91054-8DD9-448A-904B-04704F91BE5B}" srcOrd="0" destOrd="0" presId="urn:microsoft.com/office/officeart/2005/8/layout/vList2"/>
-    <dgm:cxn modelId="{44C282F8-026D-4D0E-88F8-71C8338D4947}" type="presParOf" srcId="{C74AEAA8-95AA-4DD2-B5BF-AF2613DDA678}" destId="{C717DEE2-2529-4048-A027-0347422F7B4B}" srcOrd="0" destOrd="0" presId="urn:microsoft.com/office/officeart/2005/8/layout/vList2"/>
-    <dgm:cxn modelId="{A2FC0041-DBBC-4347-B284-15C177BA5CBB}" type="presParOf" srcId="{C74AEAA8-95AA-4DD2-B5BF-AF2613DDA678}" destId="{4287A08D-B1A3-4BC4-BB02-712CE914270A}" srcOrd="1" destOrd="0" presId="urn:microsoft.com/office/officeart/2005/8/layout/vList2"/>
-    <dgm:cxn modelId="{1F231710-9268-456D-BB41-5EF6C3FF22EA}" type="presParOf" srcId="{C74AEAA8-95AA-4DD2-B5BF-AF2613DDA678}" destId="{953729D8-D97F-44F2-81C8-913FF1732DF0}" srcOrd="2" destOrd="0" presId="urn:microsoft.com/office/officeart/2005/8/layout/vList2"/>
-    <dgm:cxn modelId="{88954878-3A0B-42C4-9F81-BDE6EECAC6BB}" type="presParOf" srcId="{C74AEAA8-95AA-4DD2-B5BF-AF2613DDA678}" destId="{CFA41472-2BE5-47B1-9CB3-237F433878BD}" srcOrd="3" destOrd="0" presId="urn:microsoft.com/office/officeart/2005/8/layout/vList2"/>
-    <dgm:cxn modelId="{1D2739EB-BB59-4910-9975-95AA0CD333E3}" type="presParOf" srcId="{C74AEAA8-95AA-4DD2-B5BF-AF2613DDA678}" destId="{A8D91054-8DD9-448A-904B-04704F91BE5B}" srcOrd="4" destOrd="0" presId="urn:microsoft.com/office/officeart/2005/8/layout/vList2"/>
-    <dgm:cxn modelId="{6C79349A-7A82-495D-85CF-6DEA3A975944}" type="presParOf" srcId="{C74AEAA8-95AA-4DD2-B5BF-AF2613DDA678}" destId="{2F6E42A2-4884-4DE6-9E60-C6274C59628F}" srcOrd="5" destOrd="0" presId="urn:microsoft.com/office/officeart/2005/8/layout/vList2"/>
-    <dgm:cxn modelId="{03D2328F-7F51-477C-B02C-5D2B0B7B3522}" type="presParOf" srcId="{C74AEAA8-95AA-4DD2-B5BF-AF2613DDA678}" destId="{757879D0-74B4-423F-8DF0-7031701AE794}" srcOrd="6" destOrd="0" presId="urn:microsoft.com/office/officeart/2005/8/layout/vList2"/>
-    <dgm:cxn modelId="{E220FFE8-B560-4D87-9701-9FED24A7D28A}" type="presParOf" srcId="{C74AEAA8-95AA-4DD2-B5BF-AF2613DDA678}" destId="{B1B62F95-136D-4EA2-B1D2-CCDC609FA9EF}" srcOrd="7" destOrd="0" presId="urn:microsoft.com/office/officeart/2005/8/layout/vList2"/>
-    <dgm:cxn modelId="{6C57751A-1A6F-4AAA-B75D-272F1359EA35}" type="presParOf" srcId="{C74AEAA8-95AA-4DD2-B5BF-AF2613DDA678}" destId="{2E76E2E3-35EA-48C7-A45C-F0395CE090B2}" srcOrd="8" destOrd="0" presId="urn:microsoft.com/office/officeart/2005/8/layout/vList2"/>
+    <dgm:cxn modelId="{6128F5AF-C1A9-41F0-B2F1-8F28816F04E7}" srcId="{A8972B69-4B4F-436A-B547-1FADC4FB29B4}" destId="{EB5121E5-32EC-4CC1-8D66-D95323571777}" srcOrd="1" destOrd="0" parTransId="{688F2547-1224-41BA-B5A3-11ACD36BDE10}" sibTransId="{D6AD86F4-A6C8-4FE0-AF15-A11786D5D5A7}"/>
+    <dgm:cxn modelId="{26A444C0-0B38-4634-AD5F-1C186FFB9DD9}" type="presOf" srcId="{EB5121E5-32EC-4CC1-8D66-D95323571777}" destId="{F94D21B4-717D-44F3-A5A2-7786D04B0D36}" srcOrd="0" destOrd="0" presId="urn:microsoft.com/office/officeart/2005/8/layout/process4"/>
+    <dgm:cxn modelId="{AA7A9CC2-389C-483C-833A-85BA2F7F71E3}" type="presOf" srcId="{EB5121E5-32EC-4CC1-8D66-D95323571777}" destId="{461B57AD-775D-46BC-AF21-BF741DE08030}" srcOrd="1" destOrd="0" presId="urn:microsoft.com/office/officeart/2005/8/layout/process4"/>
+    <dgm:cxn modelId="{C3B22DCE-5D0E-437E-8154-E79603D00EB0}" type="presOf" srcId="{803D0F37-C69D-433A-8B5B-D4CF3107BCE9}" destId="{B73B748A-13E7-4DEF-98B7-3EA10A235998}" srcOrd="0" destOrd="0" presId="urn:microsoft.com/office/officeart/2005/8/layout/process4"/>
+    <dgm:cxn modelId="{30533CF7-A5A0-4A3A-8965-00558F955E74}" type="presOf" srcId="{9182D038-504A-4BAB-926D-C43E3569DBBF}" destId="{DFEB7707-965B-4E91-8967-EA2DDFBF218E}" srcOrd="0" destOrd="0" presId="urn:microsoft.com/office/officeart/2005/8/layout/process4"/>
+    <dgm:cxn modelId="{585D769B-BC63-443D-9FA0-53C8DAB66774}" type="presParOf" srcId="{C02D4931-3D53-44B6-8786-4F33D4438E16}" destId="{2F9D52CB-4845-4677-B495-47244B0A6919}" srcOrd="0" destOrd="0" presId="urn:microsoft.com/office/officeart/2005/8/layout/process4"/>
+    <dgm:cxn modelId="{E97CFB66-FF70-4107-B30F-A57E6B6A8384}" type="presParOf" srcId="{2F9D52CB-4845-4677-B495-47244B0A6919}" destId="{F94D21B4-717D-44F3-A5A2-7786D04B0D36}" srcOrd="0" destOrd="0" presId="urn:microsoft.com/office/officeart/2005/8/layout/process4"/>
+    <dgm:cxn modelId="{EE78CE6C-8BD5-4A8D-B505-A0567AADA1A0}" type="presParOf" srcId="{2F9D52CB-4845-4677-B495-47244B0A6919}" destId="{461B57AD-775D-46BC-AF21-BF741DE08030}" srcOrd="1" destOrd="0" presId="urn:microsoft.com/office/officeart/2005/8/layout/process4"/>
+    <dgm:cxn modelId="{E7D39302-13F5-4A10-A512-128E0F7A971C}" type="presParOf" srcId="{2F9D52CB-4845-4677-B495-47244B0A6919}" destId="{83951E30-0CAF-40F5-A939-932BE4AB7938}" srcOrd="2" destOrd="0" presId="urn:microsoft.com/office/officeart/2005/8/layout/process4"/>
+    <dgm:cxn modelId="{E3D32C8D-9443-4048-821F-5B1B6697B3D5}" type="presParOf" srcId="{83951E30-0CAF-40F5-A939-932BE4AB7938}" destId="{DFEB7707-965B-4E91-8967-EA2DDFBF218E}" srcOrd="0" destOrd="0" presId="urn:microsoft.com/office/officeart/2005/8/layout/process4"/>
+    <dgm:cxn modelId="{3BCE72BC-8051-4103-9A78-F725F8E4CCE6}" type="presParOf" srcId="{83951E30-0CAF-40F5-A939-932BE4AB7938}" destId="{B73B748A-13E7-4DEF-98B7-3EA10A235998}" srcOrd="1" destOrd="0" presId="urn:microsoft.com/office/officeart/2005/8/layout/process4"/>
+    <dgm:cxn modelId="{BF6079DC-B224-4217-8BB5-B3D0569542A7}" type="presParOf" srcId="{83951E30-0CAF-40F5-A939-932BE4AB7938}" destId="{AF879534-F1EC-4012-93E0-D6A87B0DF1D2}" srcOrd="2" destOrd="0" presId="urn:microsoft.com/office/officeart/2005/8/layout/process4"/>
+    <dgm:cxn modelId="{0195C394-B69D-4A68-A009-93074C77C183}" type="presParOf" srcId="{83951E30-0CAF-40F5-A939-932BE4AB7938}" destId="{0F565987-2C71-4DCF-A1C1-E0601B2C4C10}" srcOrd="3" destOrd="0" presId="urn:microsoft.com/office/officeart/2005/8/layout/process4"/>
+    <dgm:cxn modelId="{A9721079-1872-4B55-871A-045E8D59C442}" type="presParOf" srcId="{C02D4931-3D53-44B6-8786-4F33D4438E16}" destId="{9D5C837F-8017-4AB9-8994-F8CB0FDCE4BB}" srcOrd="1" destOrd="0" presId="urn:microsoft.com/office/officeart/2005/8/layout/process4"/>
+    <dgm:cxn modelId="{6D892BAF-62E3-4B31-A661-30BEE1A06D60}" type="presParOf" srcId="{C02D4931-3D53-44B6-8786-4F33D4438E16}" destId="{8A5E0D36-7A12-4198-A6F1-EA719691EE02}" srcOrd="2" destOrd="0" presId="urn:microsoft.com/office/officeart/2005/8/layout/process4"/>
+    <dgm:cxn modelId="{BC255D68-898C-49C5-84DF-ECA8561F177F}" type="presParOf" srcId="{8A5E0D36-7A12-4198-A6F1-EA719691EE02}" destId="{882C4059-4D1A-489A-A4F8-99823542DCD9}" srcOrd="0" destOrd="0" presId="urn:microsoft.com/office/officeart/2005/8/layout/process4"/>
   </dgm:cxnLst>
   <dgm:bg/>
   <dgm:whole/>
@@ -1239,17 +1316,17 @@
       <dsp:cNvGrpSpPr/>
     </dsp:nvGrpSpPr>
     <dsp:grpSpPr/>
-    <dsp:sp modelId="{C717DEE2-2529-4048-A027-0347422F7B4B}">
+    <dsp:sp modelId="{461B57AD-775D-46BC-AF21-BF741DE08030}">
       <dsp:nvSpPr>
         <dsp:cNvPr id="0" name=""/>
         <dsp:cNvSpPr/>
       </dsp:nvSpPr>
       <dsp:spPr>
         <a:xfrm>
-          <a:off x="0" y="92677"/>
-          <a:ext cx="5019610" cy="874575"/>
+          <a:off x="0" y="2911050"/>
+          <a:ext cx="5019610" cy="1909964"/>
         </a:xfrm>
-        <a:prstGeom prst="roundRect">
+        <a:prstGeom prst="rect">
           <a:avLst/>
         </a:prstGeom>
         <a:gradFill rotWithShape="0">
@@ -1303,12 +1380,12 @@
         </a:fontRef>
       </dsp:style>
       <dsp:txBody>
-        <a:bodyPr spcFirstLastPara="0" vert="horz" wrap="square" lIns="87630" tIns="87630" rIns="87630" bIns="87630" numCol="1" spcCol="1270" anchor="ctr" anchorCtr="0">
+        <a:bodyPr spcFirstLastPara="0" vert="horz" wrap="square" lIns="177800" tIns="177800" rIns="177800" bIns="177800" numCol="1" spcCol="1270" anchor="ctr" anchorCtr="0">
           <a:noAutofit/>
         </a:bodyPr>
         <a:lstStyle/>
         <a:p>
-          <a:pPr marL="0" lvl="0" indent="0" algn="l" defTabSz="1022350">
+          <a:pPr marL="0" lvl="0" indent="0" algn="ctr" defTabSz="1111250">
             <a:lnSpc>
               <a:spcPct val="90000"/>
             </a:lnSpc>
@@ -1321,86 +1398,73 @@
             <a:buNone/>
           </a:pPr>
           <a:r>
-            <a:rPr lang="en-US" sz="2300" kern="1200"/>
-            <a:t>compare two approaches</a:t>
+            <a:rPr lang="en-US" sz="2500" kern="1200" dirty="0"/>
+            <a:t>A useful revision should make the program:</a:t>
           </a:r>
         </a:p>
       </dsp:txBody>
       <dsp:txXfrm>
-        <a:off x="42693" y="135370"/>
-        <a:ext cx="4934224" cy="789189"/>
+        <a:off x="0" y="2911050"/>
+        <a:ext cx="5019610" cy="1031380"/>
       </dsp:txXfrm>
     </dsp:sp>
-    <dsp:sp modelId="{953729D8-D97F-44F2-81C8-913FF1732DF0}">
+    <dsp:sp modelId="{DFEB7707-965B-4E91-8967-EA2DDFBF218E}">
       <dsp:nvSpPr>
         <dsp:cNvPr id="0" name=""/>
         <dsp:cNvSpPr/>
       </dsp:nvSpPr>
       <dsp:spPr>
         <a:xfrm>
-          <a:off x="0" y="1033492"/>
-          <a:ext cx="5019610" cy="874575"/>
+          <a:off x="0" y="3904232"/>
+          <a:ext cx="1254902" cy="878583"/>
         </a:xfrm>
-        <a:prstGeom prst="roundRect">
+        <a:prstGeom prst="rect">
           <a:avLst/>
         </a:prstGeom>
-        <a:gradFill rotWithShape="0">
-          <a:gsLst>
-            <a:gs pos="0">
-              <a:schemeClr val="accent2">
-                <a:hueOff val="-2474057"/>
-                <a:satOff val="8986"/>
-                <a:lumOff val="834"/>
-                <a:alphaOff val="0"/>
-                <a:tint val="96000"/>
-                <a:lumMod val="100000"/>
-              </a:schemeClr>
-            </a:gs>
-            <a:gs pos="78000">
-              <a:schemeClr val="accent2">
-                <a:hueOff val="-2474057"/>
-                <a:satOff val="8986"/>
-                <a:lumOff val="834"/>
-                <a:alphaOff val="0"/>
-                <a:shade val="94000"/>
-                <a:lumMod val="94000"/>
-              </a:schemeClr>
-            </a:gs>
-          </a:gsLst>
-          <a:lin ang="5400000" scaled="0"/>
-        </a:gradFill>
-        <a:ln>
-          <a:noFill/>
+        <a:solidFill>
+          <a:schemeClr val="accent2">
+            <a:tint val="40000"/>
+            <a:alpha val="90000"/>
+            <a:hueOff val="0"/>
+            <a:satOff val="0"/>
+            <a:lumOff val="0"/>
+            <a:alphaOff val="0"/>
+          </a:schemeClr>
+        </a:solidFill>
+        <a:ln w="12700" cap="rnd" cmpd="sng" algn="ctr">
+          <a:solidFill>
+            <a:schemeClr val="accent2">
+              <a:tint val="40000"/>
+              <a:alpha val="90000"/>
+              <a:hueOff val="0"/>
+              <a:satOff val="0"/>
+              <a:lumOff val="0"/>
+              <a:alphaOff val="0"/>
+            </a:schemeClr>
+          </a:solidFill>
+          <a:prstDash val="solid"/>
         </a:ln>
-        <a:effectLst>
-          <a:outerShdw blurRad="38100" dist="25400" dir="5400000" rotWithShape="0">
-            <a:srgbClr val="000000">
-              <a:alpha val="35000"/>
-            </a:srgbClr>
-          </a:outerShdw>
-        </a:effectLst>
+        <a:effectLst/>
       </dsp:spPr>
       <dsp:style>
-        <a:lnRef idx="0">
+        <a:lnRef idx="1">
           <a:scrgbClr r="0" g="0" b="0"/>
         </a:lnRef>
-        <a:fillRef idx="3">
+        <a:fillRef idx="1">
           <a:scrgbClr r="0" g="0" b="0"/>
         </a:fillRef>
-        <a:effectRef idx="2">
+        <a:effectRef idx="0">
           <a:scrgbClr r="0" g="0" b="0"/>
         </a:effectRef>
-        <a:fontRef idx="minor">
-          <a:schemeClr val="lt1"/>
-        </a:fontRef>
+        <a:fontRef idx="minor"/>
       </dsp:style>
       <dsp:txBody>
-        <a:bodyPr spcFirstLastPara="0" vert="horz" wrap="square" lIns="87630" tIns="87630" rIns="87630" bIns="87630" numCol="1" spcCol="1270" anchor="ctr" anchorCtr="0">
+        <a:bodyPr spcFirstLastPara="0" vert="horz" wrap="square" lIns="142240" tIns="25400" rIns="142240" bIns="25400" numCol="1" spcCol="1270" anchor="ctr" anchorCtr="0">
           <a:noAutofit/>
         </a:bodyPr>
         <a:lstStyle/>
         <a:p>
-          <a:pPr marL="0" lvl="0" indent="0" algn="l" defTabSz="1022350">
+          <a:pPr marL="0" lvl="0" indent="0" algn="ctr" defTabSz="889000">
             <a:lnSpc>
               <a:spcPct val="90000"/>
             </a:lnSpc>
@@ -1413,86 +1477,73 @@
             <a:buNone/>
           </a:pPr>
           <a:r>
-            <a:rPr lang="en-US" sz="2300" kern="1200"/>
-            <a:t>collect timing evidence</a:t>
+            <a:rPr lang="en-US" sz="2000" kern="1200" dirty="0"/>
+            <a:t>clearer</a:t>
           </a:r>
         </a:p>
       </dsp:txBody>
       <dsp:txXfrm>
-        <a:off x="42693" y="1076185"/>
-        <a:ext cx="4934224" cy="789189"/>
+        <a:off x="0" y="3904232"/>
+        <a:ext cx="1254902" cy="878583"/>
       </dsp:txXfrm>
     </dsp:sp>
-    <dsp:sp modelId="{A8D91054-8DD9-448A-904B-04704F91BE5B}">
+    <dsp:sp modelId="{B73B748A-13E7-4DEF-98B7-3EA10A235998}">
       <dsp:nvSpPr>
         <dsp:cNvPr id="0" name=""/>
         <dsp:cNvSpPr/>
       </dsp:nvSpPr>
       <dsp:spPr>
         <a:xfrm>
-          <a:off x="0" y="1974307"/>
-          <a:ext cx="5019610" cy="874575"/>
+          <a:off x="1254902" y="3904232"/>
+          <a:ext cx="1254902" cy="878583"/>
         </a:xfrm>
-        <a:prstGeom prst="roundRect">
+        <a:prstGeom prst="rect">
           <a:avLst/>
         </a:prstGeom>
-        <a:gradFill rotWithShape="0">
-          <a:gsLst>
-            <a:gs pos="0">
-              <a:schemeClr val="accent2">
-                <a:hueOff val="-4948115"/>
-                <a:satOff val="17972"/>
-                <a:lumOff val="1667"/>
-                <a:alphaOff val="0"/>
-                <a:tint val="96000"/>
-                <a:lumMod val="100000"/>
-              </a:schemeClr>
-            </a:gs>
-            <a:gs pos="78000">
-              <a:schemeClr val="accent2">
-                <a:hueOff val="-4948115"/>
-                <a:satOff val="17972"/>
-                <a:lumOff val="1667"/>
-                <a:alphaOff val="0"/>
-                <a:shade val="94000"/>
-                <a:lumMod val="94000"/>
-              </a:schemeClr>
-            </a:gs>
-          </a:gsLst>
-          <a:lin ang="5400000" scaled="0"/>
-        </a:gradFill>
-        <a:ln>
-          <a:noFill/>
+        <a:solidFill>
+          <a:schemeClr val="accent2">
+            <a:tint val="40000"/>
+            <a:alpha val="90000"/>
+            <a:hueOff val="-3718424"/>
+            <a:satOff val="16208"/>
+            <a:lumOff val="1196"/>
+            <a:alphaOff val="0"/>
+          </a:schemeClr>
+        </a:solidFill>
+        <a:ln w="12700" cap="rnd" cmpd="sng" algn="ctr">
+          <a:solidFill>
+            <a:schemeClr val="accent2">
+              <a:tint val="40000"/>
+              <a:alpha val="90000"/>
+              <a:hueOff val="-3718424"/>
+              <a:satOff val="16208"/>
+              <a:lumOff val="1196"/>
+              <a:alphaOff val="0"/>
+            </a:schemeClr>
+          </a:solidFill>
+          <a:prstDash val="solid"/>
         </a:ln>
-        <a:effectLst>
-          <a:outerShdw blurRad="38100" dist="25400" dir="5400000" rotWithShape="0">
-            <a:srgbClr val="000000">
-              <a:alpha val="35000"/>
-            </a:srgbClr>
-          </a:outerShdw>
-        </a:effectLst>
+        <a:effectLst/>
       </dsp:spPr>
       <dsp:style>
-        <a:lnRef idx="0">
+        <a:lnRef idx="1">
           <a:scrgbClr r="0" g="0" b="0"/>
         </a:lnRef>
-        <a:fillRef idx="3">
+        <a:fillRef idx="1">
           <a:scrgbClr r="0" g="0" b="0"/>
         </a:fillRef>
-        <a:effectRef idx="2">
+        <a:effectRef idx="0">
           <a:scrgbClr r="0" g="0" b="0"/>
         </a:effectRef>
-        <a:fontRef idx="minor">
-          <a:schemeClr val="lt1"/>
-        </a:fontRef>
+        <a:fontRef idx="minor"/>
       </dsp:style>
       <dsp:txBody>
-        <a:bodyPr spcFirstLastPara="0" vert="horz" wrap="square" lIns="87630" tIns="87630" rIns="87630" bIns="87630" numCol="1" spcCol="1270" anchor="ctr" anchorCtr="0">
+        <a:bodyPr spcFirstLastPara="0" vert="horz" wrap="square" lIns="142240" tIns="25400" rIns="142240" bIns="25400" numCol="1" spcCol="1270" anchor="ctr" anchorCtr="0">
           <a:noAutofit/>
         </a:bodyPr>
         <a:lstStyle/>
         <a:p>
-          <a:pPr marL="0" lvl="0" indent="0" algn="l" defTabSz="1022350">
+          <a:pPr marL="0" lvl="0" indent="0" algn="ctr" defTabSz="889000">
             <a:lnSpc>
               <a:spcPct val="90000"/>
             </a:lnSpc>
@@ -1505,86 +1556,73 @@
             <a:buNone/>
           </a:pPr>
           <a:r>
-            <a:rPr lang="en-US" sz="2300" kern="1200"/>
-            <a:t>describe growth cautiously</a:t>
+            <a:rPr lang="en-US" sz="2000" kern="1200" dirty="0"/>
+            <a:t>easier to test</a:t>
           </a:r>
         </a:p>
       </dsp:txBody>
       <dsp:txXfrm>
-        <a:off x="42693" y="2017000"/>
-        <a:ext cx="4934224" cy="789189"/>
+        <a:off x="1254902" y="3904232"/>
+        <a:ext cx="1254902" cy="878583"/>
       </dsp:txXfrm>
     </dsp:sp>
-    <dsp:sp modelId="{757879D0-74B4-423F-8DF0-7031701AE794}">
+    <dsp:sp modelId="{AF879534-F1EC-4012-93E0-D6A87B0DF1D2}">
       <dsp:nvSpPr>
         <dsp:cNvPr id="0" name=""/>
         <dsp:cNvSpPr/>
       </dsp:nvSpPr>
       <dsp:spPr>
         <a:xfrm>
-          <a:off x="0" y="2915122"/>
-          <a:ext cx="5019610" cy="874575"/>
+          <a:off x="2509805" y="3904232"/>
+          <a:ext cx="1254902" cy="878583"/>
         </a:xfrm>
-        <a:prstGeom prst="roundRect">
+        <a:prstGeom prst="rect">
           <a:avLst/>
         </a:prstGeom>
-        <a:gradFill rotWithShape="0">
-          <a:gsLst>
-            <a:gs pos="0">
-              <a:schemeClr val="accent2">
-                <a:hueOff val="-7422172"/>
-                <a:satOff val="26958"/>
-                <a:lumOff val="2501"/>
-                <a:alphaOff val="0"/>
-                <a:tint val="96000"/>
-                <a:lumMod val="100000"/>
-              </a:schemeClr>
-            </a:gs>
-            <a:gs pos="78000">
-              <a:schemeClr val="accent2">
-                <a:hueOff val="-7422172"/>
-                <a:satOff val="26958"/>
-                <a:lumOff val="2501"/>
-                <a:alphaOff val="0"/>
-                <a:shade val="94000"/>
-                <a:lumMod val="94000"/>
-              </a:schemeClr>
-            </a:gs>
-          </a:gsLst>
-          <a:lin ang="5400000" scaled="0"/>
-        </a:gradFill>
-        <a:ln>
-          <a:noFill/>
+        <a:solidFill>
+          <a:schemeClr val="accent2">
+            <a:tint val="40000"/>
+            <a:alpha val="90000"/>
+            <a:hueOff val="-7436848"/>
+            <a:satOff val="32416"/>
+            <a:lumOff val="2392"/>
+            <a:alphaOff val="0"/>
+          </a:schemeClr>
+        </a:solidFill>
+        <a:ln w="12700" cap="rnd" cmpd="sng" algn="ctr">
+          <a:solidFill>
+            <a:schemeClr val="accent2">
+              <a:tint val="40000"/>
+              <a:alpha val="90000"/>
+              <a:hueOff val="-7436848"/>
+              <a:satOff val="32416"/>
+              <a:lumOff val="2392"/>
+              <a:alphaOff val="0"/>
+            </a:schemeClr>
+          </a:solidFill>
+          <a:prstDash val="solid"/>
         </a:ln>
-        <a:effectLst>
-          <a:outerShdw blurRad="38100" dist="25400" dir="5400000" rotWithShape="0">
-            <a:srgbClr val="000000">
-              <a:alpha val="35000"/>
-            </a:srgbClr>
-          </a:outerShdw>
-        </a:effectLst>
+        <a:effectLst/>
       </dsp:spPr>
       <dsp:style>
-        <a:lnRef idx="0">
+        <a:lnRef idx="1">
           <a:scrgbClr r="0" g="0" b="0"/>
         </a:lnRef>
-        <a:fillRef idx="3">
+        <a:fillRef idx="1">
           <a:scrgbClr r="0" g="0" b="0"/>
         </a:fillRef>
-        <a:effectRef idx="2">
+        <a:effectRef idx="0">
           <a:scrgbClr r="0" g="0" b="0"/>
         </a:effectRef>
-        <a:fontRef idx="minor">
-          <a:schemeClr val="lt1"/>
-        </a:fontRef>
+        <a:fontRef idx="minor"/>
       </dsp:style>
       <dsp:txBody>
-        <a:bodyPr spcFirstLastPara="0" vert="horz" wrap="square" lIns="87630" tIns="87630" rIns="87630" bIns="87630" numCol="1" spcCol="1270" anchor="ctr" anchorCtr="0">
+        <a:bodyPr spcFirstLastPara="0" vert="horz" wrap="square" lIns="142240" tIns="25400" rIns="142240" bIns="25400" numCol="1" spcCol="1270" anchor="ctr" anchorCtr="0">
           <a:noAutofit/>
         </a:bodyPr>
         <a:lstStyle/>
         <a:p>
-          <a:pPr marL="0" lvl="0" indent="0" algn="l" defTabSz="1022350">
+          <a:pPr marL="0" lvl="0" indent="0" algn="ctr" defTabSz="889000">
             <a:lnSpc>
               <a:spcPct val="90000"/>
             </a:lnSpc>
@@ -1597,27 +1635,106 @@
             <a:buNone/>
           </a:pPr>
           <a:r>
-            <a:rPr lang="en-US" sz="2300" kern="1200"/>
-            <a:t>use basic Big-O vocabulary</a:t>
+            <a:rPr lang="en-US" sz="2000" kern="1200" dirty="0"/>
+            <a:t>easier to change</a:t>
           </a:r>
         </a:p>
       </dsp:txBody>
       <dsp:txXfrm>
-        <a:off x="42693" y="2957815"/>
-        <a:ext cx="4934224" cy="789189"/>
+        <a:off x="2509805" y="3904232"/>
+        <a:ext cx="1254902" cy="878583"/>
       </dsp:txXfrm>
     </dsp:sp>
-    <dsp:sp modelId="{2E76E2E3-35EA-48C7-A45C-F0395CE090B2}">
+    <dsp:sp modelId="{0F565987-2C71-4DCF-A1C1-E0601B2C4C10}">
       <dsp:nvSpPr>
         <dsp:cNvPr id="0" name=""/>
         <dsp:cNvSpPr/>
       </dsp:nvSpPr>
       <dsp:spPr>
         <a:xfrm>
-          <a:off x="0" y="3855937"/>
-          <a:ext cx="5019610" cy="874575"/>
+          <a:off x="3764707" y="3904232"/>
+          <a:ext cx="1254902" cy="878583"/>
         </a:xfrm>
-        <a:prstGeom prst="roundRect">
+        <a:prstGeom prst="rect">
+          <a:avLst/>
+        </a:prstGeom>
+        <a:solidFill>
+          <a:schemeClr val="accent2">
+            <a:tint val="40000"/>
+            <a:alpha val="90000"/>
+            <a:hueOff val="-11155272"/>
+            <a:satOff val="48624"/>
+            <a:lumOff val="3588"/>
+            <a:alphaOff val="0"/>
+          </a:schemeClr>
+        </a:solidFill>
+        <a:ln w="12700" cap="rnd" cmpd="sng" algn="ctr">
+          <a:solidFill>
+            <a:schemeClr val="accent2">
+              <a:tint val="40000"/>
+              <a:alpha val="90000"/>
+              <a:hueOff val="-11155272"/>
+              <a:satOff val="48624"/>
+              <a:lumOff val="3588"/>
+              <a:alphaOff val="0"/>
+            </a:schemeClr>
+          </a:solidFill>
+          <a:prstDash val="solid"/>
+        </a:ln>
+        <a:effectLst/>
+      </dsp:spPr>
+      <dsp:style>
+        <a:lnRef idx="1">
+          <a:scrgbClr r="0" g="0" b="0"/>
+        </a:lnRef>
+        <a:fillRef idx="1">
+          <a:scrgbClr r="0" g="0" b="0"/>
+        </a:fillRef>
+        <a:effectRef idx="0">
+          <a:scrgbClr r="0" g="0" b="0"/>
+        </a:effectRef>
+        <a:fontRef idx="minor"/>
+      </dsp:style>
+      <dsp:txBody>
+        <a:bodyPr spcFirstLastPara="0" vert="horz" wrap="square" lIns="142240" tIns="25400" rIns="142240" bIns="25400" numCol="1" spcCol="1270" anchor="ctr" anchorCtr="0">
+          <a:noAutofit/>
+        </a:bodyPr>
+        <a:lstStyle/>
+        <a:p>
+          <a:pPr marL="0" lvl="0" indent="0" algn="ctr" defTabSz="889000">
+            <a:lnSpc>
+              <a:spcPct val="90000"/>
+            </a:lnSpc>
+            <a:spcBef>
+              <a:spcPct val="0"/>
+            </a:spcBef>
+            <a:spcAft>
+              <a:spcPct val="35000"/>
+            </a:spcAft>
+            <a:buNone/>
+          </a:pPr>
+          <a:r>
+            <a:rPr lang="en-US" sz="2000" kern="1200" dirty="0"/>
+            <a:t>easier to explain</a:t>
+          </a:r>
+        </a:p>
+      </dsp:txBody>
+      <dsp:txXfrm>
+        <a:off x="3764707" y="3904232"/>
+        <a:ext cx="1254902" cy="878583"/>
+      </dsp:txXfrm>
+    </dsp:sp>
+    <dsp:sp modelId="{882C4059-4D1A-489A-A4F8-99823542DCD9}">
+      <dsp:nvSpPr>
+        <dsp:cNvPr id="0" name=""/>
+        <dsp:cNvSpPr/>
+      </dsp:nvSpPr>
+      <dsp:spPr>
+        <a:xfrm rot="10800000">
+          <a:off x="0" y="2174"/>
+          <a:ext cx="5019610" cy="2937525"/>
+        </a:xfrm>
+        <a:prstGeom prst="upArrowCallout">
           <a:avLst/>
         </a:prstGeom>
         <a:gradFill rotWithShape="0">
@@ -1671,12 +1788,12 @@
         </a:fontRef>
       </dsp:style>
       <dsp:txBody>
-        <a:bodyPr spcFirstLastPara="0" vert="horz" wrap="square" lIns="87630" tIns="87630" rIns="87630" bIns="87630" numCol="1" spcCol="1270" anchor="ctr" anchorCtr="0">
+        <a:bodyPr spcFirstLastPara="0" vert="horz" wrap="square" lIns="177800" tIns="177800" rIns="177800" bIns="177800" numCol="1" spcCol="1270" anchor="ctr" anchorCtr="0">
           <a:noAutofit/>
         </a:bodyPr>
         <a:lstStyle/>
         <a:p>
-          <a:pPr marL="0" lvl="0" indent="0" algn="l" defTabSz="1022350">
+          <a:pPr marL="0" lvl="0" indent="0" algn="ctr" defTabSz="1111250">
             <a:lnSpc>
               <a:spcPct val="90000"/>
             </a:lnSpc>
@@ -1689,14 +1806,28 @@
             <a:buNone/>
           </a:pPr>
           <a:r>
-            <a:rPr lang="en-US" sz="2300" kern="1200"/>
-            <a:t>identify a limitation of your evidence</a:t>
+            <a:rPr lang="en-US" sz="2500" kern="1200" dirty="0"/>
+            <a:t>Working baseline -&gt;</a:t>
+          </a:r>
+          <a:br>
+            <a:rPr lang="en-US" sz="2500" kern="1200" dirty="0"/>
+          </a:br>
+          <a:r>
+            <a:rPr lang="en-US" sz="2500" kern="1200" dirty="0"/>
+            <a:t>compare structure -&gt;</a:t>
+          </a:r>
+          <a:br>
+            <a:rPr lang="en-US" sz="2500" kern="1200" dirty="0"/>
+          </a:br>
+          <a:r>
+            <a:rPr lang="en-US" sz="2500" kern="1200" dirty="0"/>
+            <a:t>revise one meaningful thing -&gt; explain the improvement.</a:t>
           </a:r>
         </a:p>
       </dsp:txBody>
-      <dsp:txXfrm>
-        <a:off x="42693" y="3898630"/>
-        <a:ext cx="4934224" cy="789189"/>
+      <dsp:txXfrm rot="10800000">
+        <a:off x="0" y="2174"/>
+        <a:ext cx="5019610" cy="1908716"/>
       </dsp:txXfrm>
     </dsp:sp>
   </dsp:spTree>
@@ -1704,12 +1835,12 @@
 </file>
 
 <file path=ppt/diagrams/layout1.xml><?xml version="1.0" encoding="utf-8"?>
-<dgm:layoutDef xmlns:dgm="http://schemas.openxmlformats.org/drawingml/2006/diagram" xmlns:a="http://schemas.openxmlformats.org/drawingml/2006/main" uniqueId="urn:microsoft.com/office/officeart/2005/8/layout/vList2">
+<dgm:layoutDef xmlns:dgm="http://schemas.openxmlformats.org/drawingml/2006/diagram" xmlns:a="http://schemas.openxmlformats.org/drawingml/2006/main" uniqueId="urn:microsoft.com/office/officeart/2005/8/layout/process4">
   <dgm:title val=""/>
   <dgm:desc val=""/>
   <dgm:catLst>
-    <dgm:cat type="list" pri="3000"/>
-    <dgm:cat type="convert" pri="1000"/>
+    <dgm:cat type="process" pri="16000"/>
+    <dgm:cat type="list" pri="20000"/>
   </dgm:catLst>
   <dgm:sampData>
     <dgm:dataModel>
@@ -1721,18 +1852,38 @@
         <dgm:pt modelId="11">
           <dgm:prSet phldr="1"/>
         </dgm:pt>
+        <dgm:pt modelId="12">
+          <dgm:prSet phldr="1"/>
+        </dgm:pt>
         <dgm:pt modelId="2">
           <dgm:prSet phldr="1"/>
         </dgm:pt>
         <dgm:pt modelId="21">
           <dgm:prSet phldr="1"/>
         </dgm:pt>
+        <dgm:pt modelId="22">
+          <dgm:prSet phldr="1"/>
+        </dgm:pt>
+        <dgm:pt modelId="3">
+          <dgm:prSet phldr="1"/>
+        </dgm:pt>
+        <dgm:pt modelId="31">
+          <dgm:prSet phldr="1"/>
+        </dgm:pt>
+        <dgm:pt modelId="32">
+          <dgm:prSet phldr="1"/>
+        </dgm:pt>
       </dgm:ptLst>
       <dgm:cxnLst>
         <dgm:cxn modelId="4" srcId="0" destId="1" srcOrd="0" destOrd="0"/>
         <dgm:cxn modelId="5" srcId="0" destId="2" srcOrd="1" destOrd="0"/>
-        <dgm:cxn modelId="12" srcId="1" destId="11" srcOrd="0" destOrd="0"/>
+        <dgm:cxn modelId="6" srcId="0" destId="3" srcOrd="2" destOrd="0"/>
+        <dgm:cxn modelId="13" srcId="1" destId="11" srcOrd="0" destOrd="0"/>
+        <dgm:cxn modelId="14" srcId="1" destId="12" srcOrd="1" destOrd="0"/>
         <dgm:cxn modelId="23" srcId="2" destId="21" srcOrd="0" destOrd="0"/>
+        <dgm:cxn modelId="24" srcId="2" destId="22" srcOrd="1" destOrd="0"/>
+        <dgm:cxn modelId="33" srcId="3" destId="31" srcOrd="0" destOrd="0"/>
+        <dgm:cxn modelId="34" srcId="3" destId="32" srcOrd="1" destOrd="0"/>
       </dgm:cxnLst>
       <dgm:bg/>
       <dgm:whole/>
@@ -1743,11 +1894,15 @@
       <dgm:ptLst>
         <dgm:pt modelId="0" type="doc"/>
         <dgm:pt modelId="1"/>
+        <dgm:pt modelId="11"/>
         <dgm:pt modelId="2"/>
+        <dgm:pt modelId="21"/>
       </dgm:ptLst>
       <dgm:cxnLst>
-        <dgm:cxn modelId="3" srcId="0" destId="1" srcOrd="0" destOrd="0"/>
-        <dgm:cxn modelId="4" srcId="0" destId="2" srcOrd="1" destOrd="0"/>
+        <dgm:cxn modelId="4" srcId="0" destId="1" srcOrd="0" destOrd="0"/>
+        <dgm:cxn modelId="5" srcId="0" destId="2" srcOrd="1" destOrd="0"/>
+        <dgm:cxn modelId="13" srcId="1" destId="11" srcOrd="0" destOrd="0"/>
+        <dgm:cxn modelId="23" srcId="2" destId="21" srcOrd="0" destOrd="0"/>
       </dgm:cxnLst>
       <dgm:bg/>
       <dgm:whole/>
@@ -1758,113 +1913,275 @@
       <dgm:ptLst>
         <dgm:pt modelId="0" type="doc"/>
         <dgm:pt modelId="1"/>
+        <dgm:pt modelId="11"/>
         <dgm:pt modelId="2"/>
+        <dgm:pt modelId="21"/>
         <dgm:pt modelId="3"/>
+        <dgm:pt modelId="31"/>
         <dgm:pt modelId="4"/>
+        <dgm:pt modelId="41"/>
       </dgm:ptLst>
       <dgm:cxnLst>
         <dgm:cxn modelId="5" srcId="0" destId="1" srcOrd="0" destOrd="0"/>
         <dgm:cxn modelId="6" srcId="0" destId="2" srcOrd="1" destOrd="0"/>
         <dgm:cxn modelId="7" srcId="0" destId="3" srcOrd="2" destOrd="0"/>
         <dgm:cxn modelId="8" srcId="0" destId="4" srcOrd="3" destOrd="0"/>
+        <dgm:cxn modelId="13" srcId="1" destId="11" srcOrd="0" destOrd="0"/>
+        <dgm:cxn modelId="23" srcId="2" destId="21" srcOrd="0" destOrd="0"/>
+        <dgm:cxn modelId="33" srcId="3" destId="31" srcOrd="0" destOrd="0"/>
+        <dgm:cxn modelId="43" srcId="4" destId="41" srcOrd="0" destOrd="0"/>
       </dgm:cxnLst>
       <dgm:bg/>
       <dgm:whole/>
     </dgm:dataModel>
   </dgm:clrData>
-  <dgm:layoutNode name="linear">
+  <dgm:layoutNode name="Name0">
     <dgm:varLst>
+      <dgm:dir/>
       <dgm:animLvl val="lvl"/>
       <dgm:resizeHandles val="exact"/>
     </dgm:varLst>
     <dgm:alg type="lin">
-      <dgm:param type="linDir" val="fromT"/>
-      <dgm:param type="vertAlign" val="mid"/>
+      <dgm:param type="linDir" val="fromB"/>
     </dgm:alg>
     <dgm:shape xmlns:r="http://schemas.openxmlformats.org/officeDocument/2006/relationships" r:blip="">
       <dgm:adjLst/>
     </dgm:shape>
     <dgm:presOf/>
     <dgm:constrLst>
-      <dgm:constr type="w" for="ch" forName="parentText" refType="w"/>
-      <dgm:constr type="h" for="ch" forName="parentText" refType="primFontSz" refFor="ch" refForName="parentText" fact="0.52"/>
-      <dgm:constr type="w" for="ch" forName="childText" refType="w"/>
-      <dgm:constr type="h" for="ch" forName="childText" refType="primFontSz" refFor="ch" refForName="parentText" fact="0.46"/>
-      <dgm:constr type="h" for="ch" forName="parentText" op="equ"/>
-      <dgm:constr type="primFontSz" for="ch" forName="parentText" op="equ" val="65"/>
-      <dgm:constr type="primFontSz" for="ch" forName="childText" refType="primFontSz" refFor="ch" refForName="parentText" op="equ"/>
-      <dgm:constr type="h" for="ch" forName="spacer" refType="primFontSz" refFor="ch" refForName="parentText" fact="0.08"/>
+      <dgm:constr type="h" for="ch" forName="boxAndChildren" refType="h"/>
+      <dgm:constr type="h" for="ch" forName="arrowAndChildren" refType="h" refFor="ch" refForName="boxAndChildren" op="equ" fact="1.538"/>
+      <dgm:constr type="w" for="ch" forName="arrowAndChildren" refType="w"/>
+      <dgm:constr type="w" for="ch" forName="boxAndChildren" refType="w"/>
+      <dgm:constr type="h" for="ch" forName="sp" refType="h" fact="-0.015"/>
+      <dgm:constr type="primFontSz" for="des" forName="parentTextBox" val="65"/>
+      <dgm:constr type="primFontSz" for="des" forName="parentTextArrow" refType="primFontSz" refFor="des" refForName="parentTextBox" op="equ"/>
+      <dgm:constr type="primFontSz" for="des" forName="childTextArrow" val="65"/>
+      <dgm:constr type="primFontSz" for="des" forName="childTextBox" refType="primFontSz" refFor="des" refForName="childTextArrow" op="equ"/>
     </dgm:constrLst>
-    <dgm:ruleLst>
-      <dgm:rule type="primFontSz" for="ch" forName="parentText" val="5" fact="NaN" max="NaN"/>
-    </dgm:ruleLst>
-    <dgm:forEach name="Name0" axis="ch" ptType="node">
-      <dgm:layoutNode name="parentText" styleLbl="node1">
-        <dgm:varLst>
-          <dgm:chMax val="0"/>
-          <dgm:bulletEnabled val="1"/>
-        </dgm:varLst>
-        <dgm:alg type="tx">
-          <dgm:param type="parTxLTRAlign" val="l"/>
-          <dgm:param type="parTxRTLAlign" val="r"/>
-        </dgm:alg>
-        <dgm:shape xmlns:r="http://schemas.openxmlformats.org/officeDocument/2006/relationships" type="roundRect" r:blip="">
-          <dgm:adjLst/>
-        </dgm:shape>
-        <dgm:presOf axis="self"/>
-        <dgm:constrLst>
-          <dgm:constr type="tMarg" refType="primFontSz" fact="0.3"/>
-          <dgm:constr type="bMarg" refType="primFontSz" fact="0.3"/>
-          <dgm:constr type="lMarg" refType="primFontSz" fact="0.3"/>
-          <dgm:constr type="rMarg" refType="primFontSz" fact="0.3"/>
-        </dgm:constrLst>
-        <dgm:ruleLst>
-          <dgm:rule type="h" val="INF" fact="NaN" max="NaN"/>
-        </dgm:ruleLst>
-      </dgm:layoutNode>
-      <dgm:choose name="Name1">
-        <dgm:if name="Name2" axis="ch" ptType="node" func="cnt" op="gte" val="1">
-          <dgm:layoutNode name="childText" styleLbl="revTx">
-            <dgm:varLst>
-              <dgm:bulletEnabled val="1"/>
-            </dgm:varLst>
-            <dgm:alg type="tx">
-              <dgm:param type="stBulletLvl" val="1"/>
-              <dgm:param type="lnSpAfChP" val="20"/>
-            </dgm:alg>
-            <dgm:shape xmlns:r="http://schemas.openxmlformats.org/officeDocument/2006/relationships" type="rect" r:blip="">
+    <dgm:ruleLst/>
+    <dgm:forEach name="Name1" axis="ch" ptType="node" st="-1" step="-1">
+      <dgm:choose name="Name2">
+        <dgm:if name="Name3" axis="self" ptType="node" func="revPos" op="equ" val="1">
+          <dgm:layoutNode name="boxAndChildren">
+            <dgm:alg type="composite"/>
+            <dgm:shape xmlns:r="http://schemas.openxmlformats.org/officeDocument/2006/relationships" r:blip="">
               <dgm:adjLst/>
             </dgm:shape>
-            <dgm:presOf axis="des" ptType="node"/>
-            <dgm:constrLst>
-              <dgm:constr type="tMarg" refType="primFontSz" fact="0.1"/>
-              <dgm:constr type="bMarg" refType="primFontSz" fact="0.1"/>
-              <dgm:constr type="lMarg" refType="w" fact="0.09"/>
-            </dgm:constrLst>
-            <dgm:ruleLst>
-              <dgm:rule type="h" val="INF" fact="NaN" max="NaN"/>
-            </dgm:ruleLst>
-          </dgm:layoutNode>
-        </dgm:if>
-        <dgm:else name="Name3">
-          <dgm:choose name="Name4">
-            <dgm:if name="Name5" axis="par ch" ptType="doc node" func="cnt" op="gte" val="2">
-              <dgm:forEach name="Name6" axis="followSib" ptType="sibTrans" cnt="1">
-                <dgm:layoutNode name="spacer">
+            <dgm:presOf/>
+            <dgm:choose name="Name4">
+              <dgm:if name="Name5" axis="ch" ptType="node" func="cnt" op="gte" val="1">
+                <dgm:constrLst>
+                  <dgm:constr type="w" for="ch" forName="parentTextBox" refType="w"/>
+                  <dgm:constr type="h" for="ch" forName="parentTextBox" refType="h" fact="0.54"/>
+                  <dgm:constr type="t" for="ch" forName="parentTextBox"/>
+                  <dgm:constr type="w" for="ch" forName="entireBox" refType="w"/>
+                  <dgm:constr type="h" for="ch" forName="entireBox" refType="h"/>
+                  <dgm:constr type="w" for="ch" forName="descendantBox" refType="w"/>
+                  <dgm:constr type="b" for="ch" forName="descendantBox" refType="h" fact="0.98"/>
+                  <dgm:constr type="h" for="ch" forName="descendantBox" refType="h" fact="0.46"/>
+                </dgm:constrLst>
+              </dgm:if>
+              <dgm:else name="Name6">
+                <dgm:constrLst>
+                  <dgm:constr type="w" for="ch" forName="parentTextBox" refType="w"/>
+                  <dgm:constr type="h" for="ch" forName="parentTextBox" refType="h"/>
+                </dgm:constrLst>
+              </dgm:else>
+            </dgm:choose>
+            <dgm:ruleLst/>
+            <dgm:layoutNode name="parentTextBox">
+              <dgm:alg type="tx"/>
+              <dgm:choose name="Name7">
+                <dgm:if name="Name8" axis="ch" ptType="node" func="cnt" op="gte" val="1">
+                  <dgm:shape xmlns:r="http://schemas.openxmlformats.org/officeDocument/2006/relationships" type="rect" r:blip="" zOrderOff="1" hideGeom="1">
+                    <dgm:adjLst/>
+                  </dgm:shape>
+                </dgm:if>
+                <dgm:else name="Name9">
+                  <dgm:shape xmlns:r="http://schemas.openxmlformats.org/officeDocument/2006/relationships" type="rect" r:blip="">
+                    <dgm:adjLst/>
+                  </dgm:shape>
+                </dgm:else>
+              </dgm:choose>
+              <dgm:presOf axis="self"/>
+              <dgm:constrLst/>
+              <dgm:ruleLst>
+                <dgm:rule type="primFontSz" val="5" fact="NaN" max="NaN"/>
+              </dgm:ruleLst>
+            </dgm:layoutNode>
+            <dgm:choose name="Name10">
+              <dgm:if name="Name11" axis="ch" ptType="node" func="cnt" op="gte" val="1">
+                <dgm:layoutNode name="entireBox">
                   <dgm:alg type="sp"/>
+                  <dgm:shape xmlns:r="http://schemas.openxmlformats.org/officeDocument/2006/relationships" type="rect" r:blip="">
+                    <dgm:adjLst/>
+                  </dgm:shape>
+                  <dgm:presOf axis="self"/>
+                  <dgm:constrLst/>
+                  <dgm:ruleLst/>
+                </dgm:layoutNode>
+                <dgm:layoutNode name="descendantBox" styleLbl="fgAccFollowNode1">
+                  <dgm:choose name="Name12">
+                    <dgm:if name="Name13" func="var" arg="dir" op="equ" val="norm">
+                      <dgm:alg type="lin"/>
+                    </dgm:if>
+                    <dgm:else name="Name14">
+                      <dgm:alg type="lin">
+                        <dgm:param type="linDir" val="fromR"/>
+                      </dgm:alg>
+                    </dgm:else>
+                  </dgm:choose>
                   <dgm:shape xmlns:r="http://schemas.openxmlformats.org/officeDocument/2006/relationships" r:blip="">
                     <dgm:adjLst/>
                   </dgm:shape>
                   <dgm:presOf/>
+                  <dgm:constrLst>
+                    <dgm:constr type="w" for="ch" forName="childTextBox" refType="w"/>
+                    <dgm:constr type="h" for="ch" forName="childTextBox" refType="h"/>
+                  </dgm:constrLst>
+                  <dgm:ruleLst/>
+                  <dgm:forEach name="Name15" axis="ch" ptType="node">
+                    <dgm:layoutNode name="childTextBox" styleLbl="fgAccFollowNode1">
+                      <dgm:varLst>
+                        <dgm:bulletEnabled val="1"/>
+                      </dgm:varLst>
+                      <dgm:alg type="tx"/>
+                      <dgm:shape xmlns:r="http://schemas.openxmlformats.org/officeDocument/2006/relationships" type="rect" r:blip="">
+                        <dgm:adjLst/>
+                      </dgm:shape>
+                      <dgm:presOf axis="desOrSelf" ptType="node"/>
+                      <dgm:constrLst>
+                        <dgm:constr type="tMarg" refType="primFontSz" fact="0.1"/>
+                        <dgm:constr type="bMarg" refType="primFontSz" fact="0.1"/>
+                      </dgm:constrLst>
+                      <dgm:ruleLst>
+                        <dgm:rule type="primFontSz" val="5" fact="NaN" max="NaN"/>
+                      </dgm:ruleLst>
+                    </dgm:layoutNode>
+                  </dgm:forEach>
+                </dgm:layoutNode>
+              </dgm:if>
+              <dgm:else name="Name16"/>
+            </dgm:choose>
+          </dgm:layoutNode>
+        </dgm:if>
+        <dgm:else name="Name17">
+          <dgm:layoutNode name="arrowAndChildren">
+            <dgm:alg type="composite"/>
+            <dgm:shape xmlns:r="http://schemas.openxmlformats.org/officeDocument/2006/relationships" r:blip="">
+              <dgm:adjLst/>
+            </dgm:shape>
+            <dgm:presOf/>
+            <dgm:choose name="Name18">
+              <dgm:if name="Name19" axis="ch" ptType="node" func="cnt" op="gte" val="1">
+                <dgm:constrLst>
+                  <dgm:constr type="w" for="ch" forName="parentTextArrow" refType="w"/>
+                  <dgm:constr type="t" for="ch" forName="parentTextArrow"/>
+                  <dgm:constr type="h" for="ch" forName="parentTextArrow" refType="h" fact="0.351"/>
+                  <dgm:constr type="w" for="ch" forName="arrow" refType="w"/>
+                  <dgm:constr type="h" for="ch" forName="arrow" refType="h"/>
+                  <dgm:constr type="w" for="ch" forName="descendantArrow" refType="w"/>
+                  <dgm:constr type="b" for="ch" forName="descendantArrow" refType="h" fact="0.65"/>
+                  <dgm:constr type="h" for="ch" forName="descendantArrow" refType="h" fact="0.299"/>
+                </dgm:constrLst>
+              </dgm:if>
+              <dgm:else name="Name20">
+                <dgm:constrLst>
+                  <dgm:constr type="w" for="ch" forName="parentTextArrow" refType="w"/>
+                  <dgm:constr type="h" for="ch" forName="parentTextArrow" refType="h"/>
+                </dgm:constrLst>
+              </dgm:else>
+            </dgm:choose>
+            <dgm:ruleLst/>
+            <dgm:layoutNode name="parentTextArrow">
+              <dgm:alg type="tx"/>
+              <dgm:choose name="Name21">
+                <dgm:if name="Name22" axis="ch" ptType="node" func="cnt" op="gte" val="1">
+                  <dgm:shape xmlns:r="http://schemas.openxmlformats.org/officeDocument/2006/relationships" type="rect" r:blip="" zOrderOff="1" hideGeom="1">
+                    <dgm:adjLst/>
+                  </dgm:shape>
+                </dgm:if>
+                <dgm:else name="Name23">
+                  <dgm:shape xmlns:r="http://schemas.openxmlformats.org/officeDocument/2006/relationships" rot="180" type="upArrowCallout" r:blip="">
+                    <dgm:adjLst/>
+                  </dgm:shape>
+                </dgm:else>
+              </dgm:choose>
+              <dgm:presOf axis="self"/>
+              <dgm:constrLst/>
+              <dgm:ruleLst>
+                <dgm:rule type="primFontSz" val="5" fact="NaN" max="NaN"/>
+              </dgm:ruleLst>
+            </dgm:layoutNode>
+            <dgm:choose name="Name24">
+              <dgm:if name="Name25" axis="ch" ptType="node" func="cnt" op="gte" val="1">
+                <dgm:layoutNode name="arrow">
+                  <dgm:alg type="sp"/>
+                  <dgm:shape xmlns:r="http://schemas.openxmlformats.org/officeDocument/2006/relationships" rot="180" type="upArrowCallout" r:blip="">
+                    <dgm:adjLst/>
+                  </dgm:shape>
+                  <dgm:presOf axis="self"/>
                   <dgm:constrLst/>
                   <dgm:ruleLst/>
                 </dgm:layoutNode>
-              </dgm:forEach>
-            </dgm:if>
-            <dgm:else name="Name7"/>
-          </dgm:choose>
+                <dgm:layoutNode name="descendantArrow">
+                  <dgm:choose name="Name26">
+                    <dgm:if name="Name27" func="var" arg="dir" op="equ" val="norm">
+                      <dgm:alg type="lin"/>
+                    </dgm:if>
+                    <dgm:else name="Name28">
+                      <dgm:alg type="lin">
+                        <dgm:param type="linDir" val="fromR"/>
+                      </dgm:alg>
+                    </dgm:else>
+                  </dgm:choose>
+                  <dgm:shape xmlns:r="http://schemas.openxmlformats.org/officeDocument/2006/relationships" r:blip="">
+                    <dgm:adjLst/>
+                  </dgm:shape>
+                  <dgm:presOf/>
+                  <dgm:constrLst>
+                    <dgm:constr type="w" for="ch" forName="childTextArrow" refType="w"/>
+                    <dgm:constr type="h" for="ch" forName="childTextArrow" refType="h"/>
+                  </dgm:constrLst>
+                  <dgm:ruleLst/>
+                  <dgm:forEach name="Name29" axis="ch" ptType="node">
+                    <dgm:layoutNode name="childTextArrow" styleLbl="fgAccFollowNode1">
+                      <dgm:varLst>
+                        <dgm:bulletEnabled val="1"/>
+                      </dgm:varLst>
+                      <dgm:alg type="tx"/>
+                      <dgm:shape xmlns:r="http://schemas.openxmlformats.org/officeDocument/2006/relationships" type="rect" r:blip="">
+                        <dgm:adjLst/>
+                      </dgm:shape>
+                      <dgm:presOf axis="desOrSelf" ptType="node"/>
+                      <dgm:constrLst>
+                        <dgm:constr type="tMarg" refType="primFontSz" fact="0.1"/>
+                        <dgm:constr type="bMarg" refType="primFontSz" fact="0.1"/>
+                      </dgm:constrLst>
+                      <dgm:ruleLst>
+                        <dgm:rule type="primFontSz" val="5" fact="NaN" max="NaN"/>
+                      </dgm:ruleLst>
+                    </dgm:layoutNode>
+                  </dgm:forEach>
+                </dgm:layoutNode>
+              </dgm:if>
+              <dgm:else name="Name30"/>
+            </dgm:choose>
+          </dgm:layoutNode>
         </dgm:else>
       </dgm:choose>
+      <dgm:forEach name="Name31" axis="precedSib" ptType="sibTrans" st="-1" cnt="1">
+        <dgm:layoutNode name="sp">
+          <dgm:alg type="sp"/>
+          <dgm:shape xmlns:r="http://schemas.openxmlformats.org/officeDocument/2006/relationships" r:blip="">
+            <dgm:adjLst/>
+          </dgm:shape>
+          <dgm:presOf axis="self"/>
+          <dgm:constrLst/>
+          <dgm:ruleLst/>
+        </dgm:layoutNode>
+      </dgm:forEach>
     </dgm:forEach>
   </dgm:layoutNode>
 </dgm:layoutDef>
@@ -2998,7 +3315,7 @@
           <a:p>
             <a:fld id="{64943E5A-6629-4B53-8BAD-0FC37077EB14}" type="datetimeFigureOut">
               <a:rPr lang="en-US" smtClean="0"/>
-              <a:t>6/11/2026</a:t>
+              <a:t>6/18/2026</a:t>
             </a:fld>
             <a:endParaRPr lang="en-US"/>
           </a:p>
@@ -3175,7 +3492,7 @@
           <a:p>
             <a:fld id="{E3382475-516A-409A-944E-F435F3DFCCF2}" type="datetimeFigureOut">
               <a:rPr lang="en-US" smtClean="0"/>
-              <a:t>6/11/2026</a:t>
+              <a:t>6/18/2026</a:t>
             </a:fld>
             <a:endParaRPr lang="en-US"/>
           </a:p>
@@ -4866,6 +5183,44 @@
           <a:bodyPr/>
           <a:lstStyle/>
           <a:p>
+            <a:r>
+              <a:rPr lang="en-US" sz="1300" b="1" dirty="0"/>
+              <a:t>**Instructor Notes:**</a:t>
+            </a:r>
+            <a:endParaRPr lang="en-US" sz="1300" dirty="0"/>
+          </a:p>
+          <a:p>
+            <a:r>
+              <a:rPr lang="en-US" sz="1300" dirty="0"/>
+              <a:t>This protects against both overbuilding and aimless polishing. </a:t>
+            </a:r>
+          </a:p>
+          <a:p>
+            <a:r>
+              <a:rPr lang="en-US" sz="1300" dirty="0"/>
+              <a:t>One meaningful improvement is enough.</a:t>
+            </a:r>
+          </a:p>
+          <a:p>
+            <a:br>
+              <a:rPr lang="en-US" sz="1300" dirty="0"/>
+            </a:br>
+            <a:endParaRPr lang="en-US" sz="1300" dirty="0"/>
+          </a:p>
+          <a:p>
+            <a:r>
+              <a:rPr lang="en-US" sz="1300" b="1" dirty="0"/>
+              <a:t>**Transition Cue:**</a:t>
+            </a:r>
+            <a:endParaRPr lang="en-US" sz="1300" dirty="0"/>
+          </a:p>
+          <a:p>
+            <a:r>
+              <a:rPr lang="en-US" sz="1300" dirty="0"/>
+              <a:t>Let's name what we will use today.</a:t>
+            </a:r>
+          </a:p>
+          <a:p>
             <a:endParaRPr lang="en-US" dirty="0"/>
           </a:p>
         </p:txBody>
@@ -5337,7 +5692,7 @@
           <a:p>
             <a:fld id="{1916ACA2-47E6-42D2-BEC8-EDC49A1A9FA1}" type="slidenum">
               <a:rPr lang="en-US" smtClean="0"/>
-              <a:t>13</a:t>
+              <a:t>12</a:t>
             </a:fld>
             <a:endParaRPr lang="en-US"/>
           </a:p>
@@ -6210,7 +6565,7 @@
           <a:p>
             <a:fld id="{5BCAD085-E8A6-8845-BD4E-CB4CCA059FC4}" type="datetimeFigureOut">
               <a:rPr lang="en-US" smtClean="0"/>
-              <a:t>6/11/2026</a:t>
+              <a:t>6/18/2026</a:t>
             </a:fld>
             <a:endParaRPr lang="en-US"/>
           </a:p>
@@ -6491,7 +6846,7 @@
           <a:p>
             <a:fld id="{5BCAD085-E8A6-8845-BD4E-CB4CCA059FC4}" type="datetimeFigureOut">
               <a:rPr lang="en-US" smtClean="0"/>
-              <a:t>6/11/2026</a:t>
+              <a:t>6/18/2026</a:t>
             </a:fld>
             <a:endParaRPr lang="en-US"/>
           </a:p>
@@ -6835,7 +7190,7 @@
           <a:p>
             <a:fld id="{5BCAD085-E8A6-8845-BD4E-CB4CCA059FC4}" type="datetimeFigureOut">
               <a:rPr lang="en-US" smtClean="0"/>
-              <a:t>6/11/2026</a:t>
+              <a:t>6/18/2026</a:t>
             </a:fld>
             <a:endParaRPr lang="en-US"/>
           </a:p>
@@ -7192,7 +7547,7 @@
           <a:p>
             <a:fld id="{5BCAD085-E8A6-8845-BD4E-CB4CCA059FC4}" type="datetimeFigureOut">
               <a:rPr lang="en-US" smtClean="0"/>
-              <a:t>6/11/2026</a:t>
+              <a:t>6/18/2026</a:t>
             </a:fld>
             <a:endParaRPr lang="en-US"/>
           </a:p>
@@ -7536,7 +7891,7 @@
           <a:p>
             <a:fld id="{5BCAD085-E8A6-8845-BD4E-CB4CCA059FC4}" type="datetimeFigureOut">
               <a:rPr lang="en-US" smtClean="0"/>
-              <a:t>6/11/2026</a:t>
+              <a:t>6/18/2026</a:t>
             </a:fld>
             <a:endParaRPr lang="en-US"/>
           </a:p>
@@ -7953,7 +8308,7 @@
           <a:p>
             <a:fld id="{5BCAD085-E8A6-8845-BD4E-CB4CCA059FC4}" type="datetimeFigureOut">
               <a:rPr lang="en-US" smtClean="0"/>
-              <a:t>6/11/2026</a:t>
+              <a:t>6/18/2026</a:t>
             </a:fld>
             <a:endParaRPr lang="en-US"/>
           </a:p>
@@ -8153,7 +8508,7 @@
           <a:p>
             <a:fld id="{5BCAD085-E8A6-8845-BD4E-CB4CCA059FC4}" type="datetimeFigureOut">
               <a:rPr lang="en-US" smtClean="0"/>
-              <a:t>6/11/2026</a:t>
+              <a:t>6/18/2026</a:t>
             </a:fld>
             <a:endParaRPr lang="en-US"/>
           </a:p>
@@ -8363,7 +8718,7 @@
           <a:p>
             <a:fld id="{5BCAD085-E8A6-8845-BD4E-CB4CCA059FC4}" type="datetimeFigureOut">
               <a:rPr lang="en-US" smtClean="0"/>
-              <a:t>6/11/2026</a:t>
+              <a:t>6/18/2026</a:t>
             </a:fld>
             <a:endParaRPr lang="en-US"/>
           </a:p>
@@ -8539,7 +8894,7 @@
           <a:p>
             <a:fld id="{5BCAD085-E8A6-8845-BD4E-CB4CCA059FC4}" type="datetimeFigureOut">
               <a:rPr lang="en-US" smtClean="0"/>
-              <a:t>6/11/2026</a:t>
+              <a:t>6/18/2026</a:t>
             </a:fld>
             <a:endParaRPr lang="en-US"/>
           </a:p>
@@ -8816,7 +9171,7 @@
           <a:p>
             <a:fld id="{5BCAD085-E8A6-8845-BD4E-CB4CCA059FC4}" type="datetimeFigureOut">
               <a:rPr lang="en-US" smtClean="0"/>
-              <a:t>6/11/2026</a:t>
+              <a:t>6/18/2026</a:t>
             </a:fld>
             <a:endParaRPr lang="en-US"/>
           </a:p>
@@ -9143,7 +9498,7 @@
           <a:p>
             <a:fld id="{5BCAD085-E8A6-8845-BD4E-CB4CCA059FC4}" type="datetimeFigureOut">
               <a:rPr lang="en-US" smtClean="0"/>
-              <a:t>6/11/2026</a:t>
+              <a:t>6/18/2026</a:t>
             </a:fld>
             <a:endParaRPr lang="en-US"/>
           </a:p>
@@ -9552,7 +9907,7 @@
           <a:p>
             <a:fld id="{5BCAD085-E8A6-8845-BD4E-CB4CCA059FC4}" type="datetimeFigureOut">
               <a:rPr lang="en-US" smtClean="0"/>
-              <a:t>6/11/2026</a:t>
+              <a:t>6/18/2026</a:t>
             </a:fld>
             <a:endParaRPr lang="en-US"/>
           </a:p>
@@ -9705,7 +10060,7 @@
           <a:p>
             <a:fld id="{5BCAD085-E8A6-8845-BD4E-CB4CCA059FC4}" type="datetimeFigureOut">
               <a:rPr lang="en-US" smtClean="0"/>
-              <a:t>6/11/2026</a:t>
+              <a:t>6/18/2026</a:t>
             </a:fld>
             <a:endParaRPr lang="en-US"/>
           </a:p>
@@ -9800,7 +10155,7 @@
           <a:p>
             <a:fld id="{5BCAD085-E8A6-8845-BD4E-CB4CCA059FC4}" type="datetimeFigureOut">
               <a:rPr lang="en-US" smtClean="0"/>
-              <a:t>6/11/2026</a:t>
+              <a:t>6/18/2026</a:t>
             </a:fld>
             <a:endParaRPr lang="en-US"/>
           </a:p>
@@ -10085,7 +10440,7 @@
           <a:p>
             <a:fld id="{5BCAD085-E8A6-8845-BD4E-CB4CCA059FC4}" type="datetimeFigureOut">
               <a:rPr lang="en-US" smtClean="0"/>
-              <a:t>6/11/2026</a:t>
+              <a:t>6/18/2026</a:t>
             </a:fld>
             <a:endParaRPr lang="en-US"/>
           </a:p>
@@ -10378,7 +10733,7 @@
           <a:p>
             <a:fld id="{5BCAD085-E8A6-8845-BD4E-CB4CCA059FC4}" type="datetimeFigureOut">
               <a:rPr lang="en-US" smtClean="0"/>
-              <a:t>6/11/2026</a:t>
+              <a:t>6/18/2026</a:t>
             </a:fld>
             <a:endParaRPr lang="en-US"/>
           </a:p>
@@ -11280,7 +11635,7 @@
           <a:p>
             <a:fld id="{5BCAD085-E8A6-8845-BD4E-CB4CCA059FC4}" type="datetimeFigureOut">
               <a:rPr lang="en-US" smtClean="0"/>
-              <a:t>6/11/2026</a:t>
+              <a:t>6/18/2026</a:t>
             </a:fld>
             <a:endParaRPr lang="en-US"/>
           </a:p>
@@ -13011,10 +13366,13 @@
       </p:grpSp>
       <p:pic>
         <p:nvPicPr>
-          <p:cNvPr id="7" name="Picture 6" descr="Camera lens close up">
+          <p:cNvPr id="7" name="Picture 6">
             <a:extLst>
               <a:ext uri="{FF2B5EF4-FFF2-40B4-BE49-F238E27FC236}">
                 <a16:creationId xmlns:a16="http://schemas.microsoft.com/office/drawing/2014/main" id="{3F92D707-4F6F-1707-563F-DAA7E83D0FDA}"/>
+              </a:ext>
+              <a:ext uri="{C183D7F6-B498-43B3-948B-1728B52AA6E4}">
+                <adec:decorative xmlns:adec="http://schemas.microsoft.com/office/drawing/2017/decorative" val="1"/>
               </a:ext>
             </a:extLst>
           </p:cNvPr>
@@ -14233,86 +14591,6 @@
 <file path=ppt/slides/slide12.xml><?xml version="1.0" encoding="utf-8"?>
 <p:sld xmlns:a="http://schemas.openxmlformats.org/drawingml/2006/main" xmlns:r="http://schemas.openxmlformats.org/officeDocument/2006/relationships" xmlns:p="http://schemas.openxmlformats.org/presentationml/2006/main">
   <p:cSld>
-    <p:spTree>
-      <p:nvGrpSpPr>
-        <p:cNvPr id="1" name=""/>
-        <p:cNvGrpSpPr/>
-        <p:nvPr/>
-      </p:nvGrpSpPr>
-      <p:grpSpPr>
-        <a:xfrm>
-          <a:off x="0" y="0"/>
-          <a:ext cx="0" cy="0"/>
-          <a:chOff x="0" y="0"/>
-          <a:chExt cx="0" cy="0"/>
-        </a:xfrm>
-      </p:grpSpPr>
-      <p:sp>
-        <p:nvSpPr>
-          <p:cNvPr id="2" name="Title 1">
-            <a:extLst>
-              <a:ext uri="{FF2B5EF4-FFF2-40B4-BE49-F238E27FC236}">
-                <a16:creationId xmlns:a16="http://schemas.microsoft.com/office/drawing/2014/main" id="{116D85B7-E617-7232-3D45-118C5B1AF291}"/>
-              </a:ext>
-            </a:extLst>
-          </p:cNvPr>
-          <p:cNvSpPr>
-            <a:spLocks noGrp="1"/>
-          </p:cNvSpPr>
-          <p:nvPr>
-            <p:ph type="title"/>
-          </p:nvPr>
-        </p:nvSpPr>
-        <p:spPr/>
-        <p:txBody>
-          <a:bodyPr/>
-          <a:lstStyle/>
-          <a:p>
-            <a:endParaRPr lang="en-US"/>
-          </a:p>
-        </p:txBody>
-      </p:sp>
-      <p:sp>
-        <p:nvSpPr>
-          <p:cNvPr id="3" name="Content Placeholder 2">
-            <a:extLst>
-              <a:ext uri="{FF2B5EF4-FFF2-40B4-BE49-F238E27FC236}">
-                <a16:creationId xmlns:a16="http://schemas.microsoft.com/office/drawing/2014/main" id="{D4623AC4-941F-5169-DAA0-DF23E55C8058}"/>
-              </a:ext>
-            </a:extLst>
-          </p:cNvPr>
-          <p:cNvSpPr>
-            <a:spLocks noGrp="1"/>
-          </p:cNvSpPr>
-          <p:nvPr>
-            <p:ph idx="1"/>
-          </p:nvPr>
-        </p:nvSpPr>
-        <p:spPr/>
-        <p:txBody>
-          <a:bodyPr/>
-          <a:lstStyle/>
-          <a:p>
-            <a:endParaRPr lang="en-US"/>
-          </a:p>
-        </p:txBody>
-      </p:sp>
-    </p:spTree>
-    <p:extLst>
-      <p:ext uri="{BB962C8B-B14F-4D97-AF65-F5344CB8AC3E}">
-        <p14:creationId xmlns:p14="http://schemas.microsoft.com/office/powerpoint/2010/main" val="1802641700"/>
-      </p:ext>
-    </p:extLst>
-  </p:cSld>
-  <p:clrMapOvr>
-    <a:masterClrMapping/>
-  </p:clrMapOvr>
-</p:sld>
-</file>
-
-<file path=ppt/slides/slide13.xml><?xml version="1.0" encoding="utf-8"?>
-<p:sld xmlns:a="http://schemas.openxmlformats.org/drawingml/2006/main" xmlns:r="http://schemas.openxmlformats.org/officeDocument/2006/relationships" xmlns:p="http://schemas.openxmlformats.org/presentationml/2006/main">
-  <p:cSld>
     <p:bg>
       <p:bgPr>
         <a:solidFill>
@@ -14365,7 +14643,7 @@
           <a:p>
             <a:r>
               <a:rPr lang="en-US" dirty="0"/>
-              <a:t>Demo Evidence</a:t>
+              <a:t>What to Watch For</a:t>
             </a:r>
           </a:p>
         </p:txBody>
@@ -14410,10 +14688,13 @@
       </p:sp>
       <p:pic>
         <p:nvPicPr>
-          <p:cNvPr id="5" name="Picture 4" descr="Magnifying glass showing decling performance">
+          <p:cNvPr id="5" name="Picture 4">
             <a:extLst>
               <a:ext uri="{FF2B5EF4-FFF2-40B4-BE49-F238E27FC236}">
                 <a16:creationId xmlns:a16="http://schemas.microsoft.com/office/drawing/2014/main" id="{0A8CDE13-EC6E-831B-0134-AE933CD2D134}"/>
+              </a:ext>
+              <a:ext uri="{C183D7F6-B498-43B3-948B-1728B52AA6E4}">
+                <adec:decorative xmlns:adec="http://schemas.microsoft.com/office/drawing/2017/decorative" val="1"/>
               </a:ext>
             </a:extLst>
           </p:cNvPr>
@@ -14634,6 +14915,86 @@
 </p:sld>
 </file>
 
+<file path=ppt/slides/slide13.xml><?xml version="1.0" encoding="utf-8"?>
+<p:sld xmlns:a="http://schemas.openxmlformats.org/drawingml/2006/main" xmlns:r="http://schemas.openxmlformats.org/officeDocument/2006/relationships" xmlns:p="http://schemas.openxmlformats.org/presentationml/2006/main">
+  <p:cSld>
+    <p:spTree>
+      <p:nvGrpSpPr>
+        <p:cNvPr id="1" name=""/>
+        <p:cNvGrpSpPr/>
+        <p:nvPr/>
+      </p:nvGrpSpPr>
+      <p:grpSpPr>
+        <a:xfrm>
+          <a:off x="0" y="0"/>
+          <a:ext cx="0" cy="0"/>
+          <a:chOff x="0" y="0"/>
+          <a:chExt cx="0" cy="0"/>
+        </a:xfrm>
+      </p:grpSpPr>
+      <p:sp>
+        <p:nvSpPr>
+          <p:cNvPr id="2" name="Title 1">
+            <a:extLst>
+              <a:ext uri="{FF2B5EF4-FFF2-40B4-BE49-F238E27FC236}">
+                <a16:creationId xmlns:a16="http://schemas.microsoft.com/office/drawing/2014/main" id="{116D85B7-E617-7232-3D45-118C5B1AF291}"/>
+              </a:ext>
+            </a:extLst>
+          </p:cNvPr>
+          <p:cNvSpPr>
+            <a:spLocks noGrp="1"/>
+          </p:cNvSpPr>
+          <p:nvPr>
+            <p:ph type="title"/>
+          </p:nvPr>
+        </p:nvSpPr>
+        <p:spPr/>
+        <p:txBody>
+          <a:bodyPr/>
+          <a:lstStyle/>
+          <a:p>
+            <a:endParaRPr lang="en-US"/>
+          </a:p>
+        </p:txBody>
+      </p:sp>
+      <p:sp>
+        <p:nvSpPr>
+          <p:cNvPr id="3" name="Content Placeholder 2">
+            <a:extLst>
+              <a:ext uri="{FF2B5EF4-FFF2-40B4-BE49-F238E27FC236}">
+                <a16:creationId xmlns:a16="http://schemas.microsoft.com/office/drawing/2014/main" id="{D4623AC4-941F-5169-DAA0-DF23E55C8058}"/>
+              </a:ext>
+            </a:extLst>
+          </p:cNvPr>
+          <p:cNvSpPr>
+            <a:spLocks noGrp="1"/>
+          </p:cNvSpPr>
+          <p:nvPr>
+            <p:ph idx="1"/>
+          </p:nvPr>
+        </p:nvSpPr>
+        <p:spPr/>
+        <p:txBody>
+          <a:bodyPr/>
+          <a:lstStyle/>
+          <a:p>
+            <a:endParaRPr lang="en-US"/>
+          </a:p>
+        </p:txBody>
+      </p:sp>
+    </p:spTree>
+    <p:extLst>
+      <p:ext uri="{BB962C8B-B14F-4D97-AF65-F5344CB8AC3E}">
+        <p14:creationId xmlns:p14="http://schemas.microsoft.com/office/powerpoint/2010/main" val="1802641700"/>
+      </p:ext>
+    </p:extLst>
+  </p:cSld>
+  <p:clrMapOvr>
+    <a:masterClrMapping/>
+  </p:clrMapOvr>
+</p:sld>
+</file>
+
 <file path=ppt/slides/slide14.xml><?xml version="1.0" encoding="utf-8"?>
 <p:sld xmlns:a="http://schemas.openxmlformats.org/drawingml/2006/main" xmlns:r="http://schemas.openxmlformats.org/officeDocument/2006/relationships" xmlns:p="http://schemas.openxmlformats.org/presentationml/2006/main">
   <p:cSld>
@@ -14696,10 +15057,13 @@
       </p:sp>
       <p:pic>
         <p:nvPicPr>
-          <p:cNvPr id="5" name="Picture 4" descr="Dark blue shattered geometric chain">
+          <p:cNvPr id="5" name="Picture 4">
             <a:extLst>
               <a:ext uri="{FF2B5EF4-FFF2-40B4-BE49-F238E27FC236}">
                 <a16:creationId xmlns:a16="http://schemas.microsoft.com/office/drawing/2014/main" id="{377F6D4D-BE10-60D9-4BD4-003EB5B66673}"/>
+              </a:ext>
+              <a:ext uri="{C183D7F6-B498-43B3-948B-1728B52AA6E4}">
+                <adec:decorative xmlns:adec="http://schemas.microsoft.com/office/drawing/2017/decorative" val="1"/>
               </a:ext>
             </a:extLst>
           </p:cNvPr>
@@ -14877,6 +15241,14 @@
 <file path=ppt/slides/slide15.xml><?xml version="1.0" encoding="utf-8"?>
 <p:sld xmlns:a="http://schemas.openxmlformats.org/drawingml/2006/main" xmlns:r="http://schemas.openxmlformats.org/officeDocument/2006/relationships" xmlns:p="http://schemas.openxmlformats.org/presentationml/2006/main">
   <p:cSld>
+    <p:bg>
+      <p:bgPr>
+        <a:solidFill>
+          <a:schemeClr val="bg1"/>
+        </a:solidFill>
+        <a:effectLst/>
+      </p:bgPr>
+    </p:bg>
     <p:spTree>
       <p:nvGrpSpPr>
         <p:cNvPr id="1" name=""/>
@@ -14962,14 +15334,23 @@
               <a:t>In Lab 0n</a:t>
             </a:r>
           </a:p>
+          <a:p>
+            <a:pPr marL="0" indent="0">
+              <a:buNone/>
+            </a:pPr>
+            <a:endParaRPr lang="en-US" dirty="0"/>
+          </a:p>
         </p:txBody>
       </p:sp>
       <p:pic>
         <p:nvPicPr>
-          <p:cNvPr id="5" name="Picture 4" descr="A row of samples for medical testing">
+          <p:cNvPr id="5" name="Picture 4">
             <a:extLst>
               <a:ext uri="{FF2B5EF4-FFF2-40B4-BE49-F238E27FC236}">
                 <a16:creationId xmlns:a16="http://schemas.microsoft.com/office/drawing/2014/main" id="{5406C1C5-46D3-5662-C887-3DA2319E776C}"/>
+              </a:ext>
+              <a:ext uri="{C183D7F6-B498-43B3-948B-1728B52AA6E4}">
+                <adec:decorative xmlns:adec="http://schemas.microsoft.com/office/drawing/2017/decorative" val="1"/>
               </a:ext>
             </a:extLst>
           </p:cNvPr>
@@ -14980,7 +15361,7 @@
         </p:nvPicPr>
         <p:blipFill>
           <a:blip r:embed="rId3"/>
-          <a:srcRect l="51375" r="4376"/>
+          <a:srcRect l="51361" r="4389"/>
           <a:stretch>
             <a:fillRect/>
           </a:stretch>
@@ -15022,6 +15403,69 @@
           </a:custGeom>
         </p:spPr>
       </p:pic>
+      <p:sp>
+        <p:nvSpPr>
+          <p:cNvPr id="10" name="Isosceles Triangle 9">
+            <a:extLst>
+              <a:ext uri="{FF2B5EF4-FFF2-40B4-BE49-F238E27FC236}">
+                <a16:creationId xmlns:a16="http://schemas.microsoft.com/office/drawing/2014/main" id="{3BCB5F6A-9EB0-40B0-9D13-3023E9A20508}"/>
+              </a:ext>
+              <a:ext uri="{C183D7F6-B498-43B3-948B-1728B52AA6E4}">
+                <adec:decorative xmlns:adec="http://schemas.microsoft.com/office/drawing/2017/decorative" val="1"/>
+              </a:ext>
+            </a:extLst>
+          </p:cNvPr>
+          <p:cNvSpPr>
+            <a:spLocks noGrp="1" noRot="1" noChangeAspect="1" noMove="1" noResize="1" noEditPoints="1" noAdjustHandles="1" noChangeArrowheads="1" noChangeShapeType="1" noTextEdit="1"/>
+          </p:cNvSpPr>
+          <p:nvPr>
+            <p:extLst>
+              <p:ext uri="{386F3935-93C4-4BCD-93E2-E3B085C9AB24}">
+                <p16:designElem xmlns:p16="http://schemas.microsoft.com/office/powerpoint/2015/main" val="1"/>
+              </p:ext>
+            </p:extLst>
+          </p:nvPr>
+        </p:nvSpPr>
+        <p:spPr>
+          <a:xfrm rot="10800000">
+            <a:off x="0" y="0"/>
+            <a:ext cx="631947" cy="5666154"/>
+          </a:xfrm>
+          <a:prstGeom prst="triangle">
+            <a:avLst>
+              <a:gd name="adj" fmla="val 100000"/>
+            </a:avLst>
+          </a:prstGeom>
+          <a:solidFill>
+            <a:schemeClr val="accent1"/>
+          </a:solidFill>
+          <a:ln>
+            <a:noFill/>
+          </a:ln>
+          <a:effectLst/>
+        </p:spPr>
+        <p:style>
+          <a:lnRef idx="1">
+            <a:schemeClr val="accent1"/>
+          </a:lnRef>
+          <a:fillRef idx="3">
+            <a:schemeClr val="accent1"/>
+          </a:fillRef>
+          <a:effectRef idx="2">
+            <a:schemeClr val="accent1"/>
+          </a:effectRef>
+          <a:fontRef idx="minor">
+            <a:schemeClr val="lt1"/>
+          </a:fontRef>
+        </p:style>
+        <p:txBody>
+          <a:bodyPr/>
+          <a:lstStyle/>
+          <a:p>
+            <a:endParaRPr lang="en-US"/>
+          </a:p>
+        </p:txBody>
+      </p:sp>
     </p:spTree>
     <p:extLst>
       <p:ext uri="{BB962C8B-B14F-4D97-AF65-F5344CB8AC3E}">
@@ -15291,10 +15735,13 @@
       </p:sp>
       <p:pic>
         <p:nvPicPr>
-          <p:cNvPr id="5" name="Picture 4" descr="Robot operating a machine">
+          <p:cNvPr id="5" name="Picture 4">
             <a:extLst>
               <a:ext uri="{FF2B5EF4-FFF2-40B4-BE49-F238E27FC236}">
                 <a16:creationId xmlns:a16="http://schemas.microsoft.com/office/drawing/2014/main" id="{638035A6-8F2B-CFAB-F2A0-C40F7D534C83}"/>
+              </a:ext>
+              <a:ext uri="{C183D7F6-B498-43B3-948B-1728B52AA6E4}">
+                <adec:decorative xmlns:adec="http://schemas.microsoft.com/office/drawing/2017/decorative" val="1"/>
               </a:ext>
             </a:extLst>
           </p:cNvPr>
@@ -15483,7 +15930,7 @@
             </a:pPr>
             <a:r>
               <a:rPr lang="en-US" sz="3100" dirty="0"/>
-              <a:t>Lab 0n Success Check</a:t>
+              <a:t>Closing Success Check</a:t>
             </a:r>
           </a:p>
         </p:txBody>
@@ -15525,10 +15972,13 @@
       </p:sp>
       <p:pic>
         <p:nvPicPr>
-          <p:cNvPr id="5" name="Picture 4" descr="Beakers with solution on shelf in lab">
+          <p:cNvPr id="5" name="Picture 4">
             <a:extLst>
               <a:ext uri="{FF2B5EF4-FFF2-40B4-BE49-F238E27FC236}">
                 <a16:creationId xmlns:a16="http://schemas.microsoft.com/office/drawing/2014/main" id="{255A690D-4CB8-0C66-184B-33949F8D651C}"/>
+              </a:ext>
+              <a:ext uri="{C183D7F6-B498-43B3-948B-1728B52AA6E4}">
+                <adec:decorative xmlns:adec="http://schemas.microsoft.com/office/drawing/2017/decorative" val="1"/>
               </a:ext>
             </a:extLst>
           </p:cNvPr>
@@ -16821,10 +17271,13 @@
       </p:sp>
       <p:pic>
         <p:nvPicPr>
-          <p:cNvPr id="21" name="Picture 20" descr="Computer code representation.">
+          <p:cNvPr id="21" name="Picture 20">
             <a:extLst>
               <a:ext uri="{FF2B5EF4-FFF2-40B4-BE49-F238E27FC236}">
                 <a16:creationId xmlns:a16="http://schemas.microsoft.com/office/drawing/2014/main" id="{8A728018-283E-379A-70A7-867E4A3D7239}"/>
+              </a:ext>
+              <a:ext uri="{C183D7F6-B498-43B3-948B-1728B52AA6E4}">
+                <adec:decorative xmlns:adec="http://schemas.microsoft.com/office/drawing/2017/decorative" val="1"/>
               </a:ext>
             </a:extLst>
           </p:cNvPr>
@@ -17080,7 +17533,7 @@
         </p:nvSpPr>
         <p:spPr>
           <a:xfrm>
-            <a:off x="739476" y="4473227"/>
+            <a:off x="739476" y="5021551"/>
             <a:ext cx="6216024" cy="1096648"/>
           </a:xfrm>
         </p:spPr>
@@ -17090,6 +17543,7 @@
           </a:bodyPr>
           <a:lstStyle/>
           <a:p>
+            <a:pPr algn="ctr"/>
             <a:r>
               <a:rPr lang="en-US" sz="4200" dirty="0"/>
               <a:t>Image Slide</a:t>
@@ -17264,6 +17718,9 @@
               <a:ext uri="{FF2B5EF4-FFF2-40B4-BE49-F238E27FC236}">
                 <a16:creationId xmlns:a16="http://schemas.microsoft.com/office/drawing/2014/main" id="{77C0D926-DDB4-ABA2-F676-65368B8023E4}"/>
               </a:ext>
+              <a:ext uri="{C183D7F6-B498-43B3-948B-1728B52AA6E4}">
+                <adec:decorative xmlns:adec="http://schemas.microsoft.com/office/drawing/2017/decorative" val="1"/>
+              </a:ext>
             </a:extLst>
           </p:cNvPr>
           <p:cNvPicPr>
@@ -18436,10 +18893,13 @@
       </p:sp>
       <p:pic>
         <p:nvPicPr>
-          <p:cNvPr id="28" name="Picture 27" descr="Computer script on a screen">
+          <p:cNvPr id="28" name="Picture 27">
             <a:extLst>
               <a:ext uri="{FF2B5EF4-FFF2-40B4-BE49-F238E27FC236}">
                 <a16:creationId xmlns:a16="http://schemas.microsoft.com/office/drawing/2014/main" id="{38D50984-DDEB-A743-533E-89C11F357B8D}"/>
+              </a:ext>
+              <a:ext uri="{C183D7F6-B498-43B3-948B-1728B52AA6E4}">
+                <adec:decorative xmlns:adec="http://schemas.microsoft.com/office/drawing/2017/decorative" val="1"/>
               </a:ext>
             </a:extLst>
           </p:cNvPr>
@@ -19627,10 +20087,13 @@
       </p:sp>
       <p:pic>
         <p:nvPicPr>
-          <p:cNvPr id="5" name="Picture 4" descr="Computer script on a screen">
+          <p:cNvPr id="5" name="Picture 4">
             <a:extLst>
               <a:ext uri="{FF2B5EF4-FFF2-40B4-BE49-F238E27FC236}">
                 <a16:creationId xmlns:a16="http://schemas.microsoft.com/office/drawing/2014/main" id="{9DC68C51-4C04-4FB3-8831-97CAFAF56E58}"/>
+              </a:ext>
+              <a:ext uri="{C183D7F6-B498-43B3-948B-1728B52AA6E4}">
+                <adec:decorative xmlns:adec="http://schemas.microsoft.com/office/drawing/2017/decorative" val="1"/>
               </a:ext>
             </a:extLst>
           </p:cNvPr>
@@ -19672,14 +20135,6 @@
 <file path=ppt/slides/slide7.xml><?xml version="1.0" encoding="utf-8"?>
 <p:sld xmlns:a="http://schemas.openxmlformats.org/drawingml/2006/main" xmlns:r="http://schemas.openxmlformats.org/officeDocument/2006/relationships" xmlns:p="http://schemas.openxmlformats.org/presentationml/2006/main">
   <p:cSld>
-    <p:bg>
-      <p:bgPr>
-        <a:solidFill>
-          <a:schemeClr val="bg1"/>
-        </a:solidFill>
-        <a:effectLst/>
-      </p:bgPr>
-    </p:bg>
     <p:spTree>
       <p:nvGrpSpPr>
         <p:cNvPr id="1" name=""/>
@@ -19694,757 +20149,6 @@
           <a:chExt cx="0" cy="0"/>
         </a:xfrm>
       </p:grpSpPr>
-      <p:sp useBgFill="1">
-        <p:nvSpPr>
-          <p:cNvPr id="9" name="Rectangle 8">
-            <a:extLst>
-              <a:ext uri="{FF2B5EF4-FFF2-40B4-BE49-F238E27FC236}">
-                <a16:creationId xmlns:a16="http://schemas.microsoft.com/office/drawing/2014/main" id="{80265050-FD84-47EF-A163-6A481836C14E}"/>
-              </a:ext>
-              <a:ext uri="{C183D7F6-B498-43B3-948B-1728B52AA6E4}">
-                <adec:decorative xmlns:adec="http://schemas.microsoft.com/office/drawing/2017/decorative" val="1"/>
-              </a:ext>
-            </a:extLst>
-          </p:cNvPr>
-          <p:cNvSpPr>
-            <a:spLocks noGrp="1" noRot="1" noChangeAspect="1" noMove="1" noResize="1" noEditPoints="1" noAdjustHandles="1" noChangeArrowheads="1" noChangeShapeType="1" noTextEdit="1"/>
-          </p:cNvSpPr>
-          <p:nvPr>
-            <p:extLst>
-              <p:ext uri="{386F3935-93C4-4BCD-93E2-E3B085C9AB24}">
-                <p16:designElem xmlns:p16="http://schemas.microsoft.com/office/powerpoint/2015/main" val="1"/>
-              </p:ext>
-            </p:extLst>
-          </p:nvPr>
-        </p:nvSpPr>
-        <p:spPr>
-          <a:xfrm>
-            <a:off x="0" y="0"/>
-            <a:ext cx="9144000" cy="6858000"/>
-          </a:xfrm>
-          <a:prstGeom prst="rect">
-            <a:avLst/>
-          </a:prstGeom>
-          <a:ln>
-            <a:noFill/>
-          </a:ln>
-        </p:spPr>
-        <p:style>
-          <a:lnRef idx="2">
-            <a:schemeClr val="accent1">
-              <a:shade val="50000"/>
-            </a:schemeClr>
-          </a:lnRef>
-          <a:fillRef idx="1">
-            <a:schemeClr val="accent1"/>
-          </a:fillRef>
-          <a:effectRef idx="0">
-            <a:schemeClr val="accent1"/>
-          </a:effectRef>
-          <a:fontRef idx="minor">
-            <a:schemeClr val="lt1"/>
-          </a:fontRef>
-        </p:style>
-        <p:txBody>
-          <a:bodyPr rtlCol="0" anchor="ctr"/>
-          <a:lstStyle/>
-          <a:p>
-            <a:pPr algn="ctr"/>
-            <a:endParaRPr lang="en-US"/>
-          </a:p>
-        </p:txBody>
-      </p:sp>
-      <p:grpSp>
-        <p:nvGrpSpPr>
-          <p:cNvPr id="11" name="Group 10">
-            <a:extLst>
-              <a:ext uri="{FF2B5EF4-FFF2-40B4-BE49-F238E27FC236}">
-                <a16:creationId xmlns:a16="http://schemas.microsoft.com/office/drawing/2014/main" id="{A11B064D-F4EB-4312-AEEA-6AFDB257E7C6}"/>
-              </a:ext>
-              <a:ext uri="{C183D7F6-B498-43B3-948B-1728B52AA6E4}">
-                <adec:decorative xmlns:adec="http://schemas.microsoft.com/office/drawing/2017/decorative" val="1"/>
-              </a:ext>
-            </a:extLst>
-          </p:cNvPr>
-          <p:cNvGrpSpPr>
-            <a:grpSpLocks noGrp="1" noUngrp="1" noRot="1" noChangeAspect="1" noMove="1" noResize="1"/>
-          </p:cNvGrpSpPr>
-          <p:nvPr>
-            <p:extLst>
-              <p:ext uri="{386F3935-93C4-4BCD-93E2-E3B085C9AB24}">
-                <p16:designElem xmlns:p16="http://schemas.microsoft.com/office/powerpoint/2015/main" val="1"/>
-              </p:ext>
-            </p:extLst>
-          </p:nvPr>
-        </p:nvGrpSpPr>
-        <p:grpSpPr>
-          <a:xfrm>
-            <a:off x="734303" y="-8467"/>
-            <a:ext cx="3575050" cy="6866467"/>
-            <a:chOff x="7425267" y="-8467"/>
-            <a:chExt cx="4766733" cy="6866467"/>
-          </a:xfrm>
-        </p:grpSpPr>
-        <p:cxnSp>
-          <p:nvCxnSpPr>
-            <p:cNvPr id="12" name="Straight Connector 11">
-              <a:extLst>
-                <a:ext uri="{FF2B5EF4-FFF2-40B4-BE49-F238E27FC236}">
-                  <a16:creationId xmlns:a16="http://schemas.microsoft.com/office/drawing/2014/main" id="{E7041201-C3DD-4181-B0E0-5C960FFE5358}"/>
-                </a:ext>
-                <a:ext uri="{C183D7F6-B498-43B3-948B-1728B52AA6E4}">
-                  <adec:decorative xmlns:adec="http://schemas.microsoft.com/office/drawing/2017/decorative" val="1"/>
-                </a:ext>
-              </a:extLst>
-            </p:cNvPr>
-            <p:cNvCxnSpPr/>
-            <p:nvPr>
-              <p:extLst>
-                <p:ext uri="{386F3935-93C4-4BCD-93E2-E3B085C9AB24}">
-                  <p16:designElem xmlns:p16="http://schemas.microsoft.com/office/powerpoint/2015/main" val="1"/>
-                </p:ext>
-              </p:extLst>
-            </p:nvPr>
-          </p:nvCxnSpPr>
-          <p:spPr>
-            <a:xfrm>
-              <a:off x="9371012" y="0"/>
-              <a:ext cx="1219200" cy="6858000"/>
-            </a:xfrm>
-            <a:prstGeom prst="line">
-              <a:avLst/>
-            </a:prstGeom>
-            <a:ln w="9525">
-              <a:solidFill>
-                <a:srgbClr val="BFBFBF">
-                  <a:alpha val="75000"/>
-                </a:srgbClr>
-              </a:solidFill>
-            </a:ln>
-          </p:spPr>
-          <p:style>
-            <a:lnRef idx="2">
-              <a:schemeClr val="accent1"/>
-            </a:lnRef>
-            <a:fillRef idx="0">
-              <a:schemeClr val="accent1"/>
-            </a:fillRef>
-            <a:effectRef idx="1">
-              <a:schemeClr val="accent1"/>
-            </a:effectRef>
-            <a:fontRef idx="minor">
-              <a:schemeClr val="tx1"/>
-            </a:fontRef>
-          </p:style>
-        </p:cxnSp>
-        <p:cxnSp>
-          <p:nvCxnSpPr>
-            <p:cNvPr id="13" name="Straight Connector 12">
-              <a:extLst>
-                <a:ext uri="{FF2B5EF4-FFF2-40B4-BE49-F238E27FC236}">
-                  <a16:creationId xmlns:a16="http://schemas.microsoft.com/office/drawing/2014/main" id="{929A678F-8D0F-4F98-85A6-797199C550FC}"/>
-                </a:ext>
-                <a:ext uri="{C183D7F6-B498-43B3-948B-1728B52AA6E4}">
-                  <adec:decorative xmlns:adec="http://schemas.microsoft.com/office/drawing/2017/decorative" val="1"/>
-                </a:ext>
-              </a:extLst>
-            </p:cNvPr>
-            <p:cNvCxnSpPr/>
-            <p:nvPr>
-              <p:extLst>
-                <p:ext uri="{386F3935-93C4-4BCD-93E2-E3B085C9AB24}">
-                  <p16:designElem xmlns:p16="http://schemas.microsoft.com/office/powerpoint/2015/main" val="1"/>
-                </p:ext>
-              </p:extLst>
-            </p:nvPr>
-          </p:nvCxnSpPr>
-          <p:spPr>
-            <a:xfrm flipH="1">
-              <a:off x="7425267" y="3681413"/>
-              <a:ext cx="4763558" cy="3176587"/>
-            </a:xfrm>
-            <a:prstGeom prst="line">
-              <a:avLst/>
-            </a:prstGeom>
-            <a:ln w="9525">
-              <a:solidFill>
-                <a:srgbClr val="BFBFBF">
-                  <a:alpha val="80000"/>
-                </a:srgbClr>
-              </a:solidFill>
-            </a:ln>
-          </p:spPr>
-          <p:style>
-            <a:lnRef idx="2">
-              <a:schemeClr val="accent1"/>
-            </a:lnRef>
-            <a:fillRef idx="0">
-              <a:schemeClr val="accent1"/>
-            </a:fillRef>
-            <a:effectRef idx="1">
-              <a:schemeClr val="accent1"/>
-            </a:effectRef>
-            <a:fontRef idx="minor">
-              <a:schemeClr val="tx1"/>
-            </a:fontRef>
-          </p:style>
-        </p:cxnSp>
-        <p:sp>
-          <p:nvSpPr>
-            <p:cNvPr id="14" name="Rectangle 23">
-              <a:extLst>
-                <a:ext uri="{FF2B5EF4-FFF2-40B4-BE49-F238E27FC236}">
-                  <a16:creationId xmlns:a16="http://schemas.microsoft.com/office/drawing/2014/main" id="{82463FFC-4B08-4AF2-AC5A-F681CE977261}"/>
-                </a:ext>
-                <a:ext uri="{C183D7F6-B498-43B3-948B-1728B52AA6E4}">
-                  <adec:decorative xmlns:adec="http://schemas.microsoft.com/office/drawing/2017/decorative" val="1"/>
-                </a:ext>
-              </a:extLst>
-            </p:cNvPr>
-            <p:cNvSpPr/>
-            <p:nvPr>
-              <p:extLst>
-                <p:ext uri="{386F3935-93C4-4BCD-93E2-E3B085C9AB24}">
-                  <p16:designElem xmlns:p16="http://schemas.microsoft.com/office/powerpoint/2015/main" val="1"/>
-                </p:ext>
-              </p:extLst>
-            </p:nvPr>
-          </p:nvSpPr>
-          <p:spPr>
-            <a:xfrm>
-              <a:off x="9181476" y="-8467"/>
-              <a:ext cx="3007349" cy="6866467"/>
-            </a:xfrm>
-            <a:custGeom>
-              <a:avLst/>
-              <a:gdLst/>
-              <a:ahLst/>
-              <a:cxnLst/>
-              <a:rect l="l" t="t" r="r" b="b"/>
-              <a:pathLst>
-                <a:path w="3007349" h="6866467">
-                  <a:moveTo>
-                    <a:pt x="2045532" y="0"/>
-                  </a:moveTo>
-                  <a:lnTo>
-                    <a:pt x="3007349" y="0"/>
-                  </a:lnTo>
-                  <a:lnTo>
-                    <a:pt x="3007349" y="6866467"/>
-                  </a:lnTo>
-                  <a:lnTo>
-                    <a:pt x="0" y="6866467"/>
-                  </a:lnTo>
-                  <a:lnTo>
-                    <a:pt x="2045532" y="0"/>
-                  </a:lnTo>
-                  <a:close/>
-                </a:path>
-              </a:pathLst>
-            </a:custGeom>
-            <a:solidFill>
-              <a:schemeClr val="accent1">
-                <a:alpha val="30000"/>
-              </a:schemeClr>
-            </a:solidFill>
-            <a:ln>
-              <a:noFill/>
-            </a:ln>
-            <a:effectLst/>
-          </p:spPr>
-          <p:style>
-            <a:lnRef idx="1">
-              <a:schemeClr val="accent1"/>
-            </a:lnRef>
-            <a:fillRef idx="3">
-              <a:schemeClr val="accent1"/>
-            </a:fillRef>
-            <a:effectRef idx="2">
-              <a:schemeClr val="accent1"/>
-            </a:effectRef>
-            <a:fontRef idx="minor">
-              <a:schemeClr val="lt1"/>
-            </a:fontRef>
-          </p:style>
-          <p:txBody>
-            <a:bodyPr/>
-            <a:lstStyle/>
-            <a:p>
-              <a:endParaRPr lang="en-US"/>
-            </a:p>
-          </p:txBody>
-        </p:sp>
-        <p:sp>
-          <p:nvSpPr>
-            <p:cNvPr id="15" name="Rectangle 25">
-              <a:extLst>
-                <a:ext uri="{FF2B5EF4-FFF2-40B4-BE49-F238E27FC236}">
-                  <a16:creationId xmlns:a16="http://schemas.microsoft.com/office/drawing/2014/main" id="{87C110A9-8F54-42F4-9B19-8D33F94DE554}"/>
-                </a:ext>
-                <a:ext uri="{C183D7F6-B498-43B3-948B-1728B52AA6E4}">
-                  <adec:decorative xmlns:adec="http://schemas.microsoft.com/office/drawing/2017/decorative" val="1"/>
-                </a:ext>
-              </a:extLst>
-            </p:cNvPr>
-            <p:cNvSpPr/>
-            <p:nvPr>
-              <p:extLst>
-                <p:ext uri="{386F3935-93C4-4BCD-93E2-E3B085C9AB24}">
-                  <p16:designElem xmlns:p16="http://schemas.microsoft.com/office/powerpoint/2015/main" val="1"/>
-                </p:ext>
-              </p:extLst>
-            </p:nvPr>
-          </p:nvSpPr>
-          <p:spPr>
-            <a:xfrm>
-              <a:off x="9603442" y="-8467"/>
-              <a:ext cx="2588558" cy="6866467"/>
-            </a:xfrm>
-            <a:custGeom>
-              <a:avLst/>
-              <a:gdLst/>
-              <a:ahLst/>
-              <a:cxnLst/>
-              <a:rect l="l" t="t" r="r" b="b"/>
-              <a:pathLst>
-                <a:path w="2573311" h="6866467">
-                  <a:moveTo>
-                    <a:pt x="0" y="0"/>
-                  </a:moveTo>
-                  <a:lnTo>
-                    <a:pt x="2573311" y="0"/>
-                  </a:lnTo>
-                  <a:lnTo>
-                    <a:pt x="2573311" y="6866467"/>
-                  </a:lnTo>
-                  <a:lnTo>
-                    <a:pt x="1202336" y="6866467"/>
-                  </a:lnTo>
-                  <a:lnTo>
-                    <a:pt x="0" y="0"/>
-                  </a:lnTo>
-                  <a:close/>
-                </a:path>
-              </a:pathLst>
-            </a:custGeom>
-            <a:solidFill>
-              <a:schemeClr val="accent1">
-                <a:alpha val="20000"/>
-              </a:schemeClr>
-            </a:solidFill>
-            <a:ln>
-              <a:noFill/>
-            </a:ln>
-            <a:effectLst/>
-          </p:spPr>
-          <p:style>
-            <a:lnRef idx="1">
-              <a:schemeClr val="accent1"/>
-            </a:lnRef>
-            <a:fillRef idx="3">
-              <a:schemeClr val="accent1"/>
-            </a:fillRef>
-            <a:effectRef idx="2">
-              <a:schemeClr val="accent1"/>
-            </a:effectRef>
-            <a:fontRef idx="minor">
-              <a:schemeClr val="lt1"/>
-            </a:fontRef>
-          </p:style>
-          <p:txBody>
-            <a:bodyPr/>
-            <a:lstStyle/>
-            <a:p>
-              <a:endParaRPr lang="en-US"/>
-            </a:p>
-          </p:txBody>
-        </p:sp>
-        <p:sp>
-          <p:nvSpPr>
-            <p:cNvPr id="16" name="Isosceles Triangle 15">
-              <a:extLst>
-                <a:ext uri="{FF2B5EF4-FFF2-40B4-BE49-F238E27FC236}">
-                  <a16:creationId xmlns:a16="http://schemas.microsoft.com/office/drawing/2014/main" id="{9F5AD5FC-19DB-4C66-BDDA-043A6AAC9448}"/>
-                </a:ext>
-                <a:ext uri="{C183D7F6-B498-43B3-948B-1728B52AA6E4}">
-                  <adec:decorative xmlns:adec="http://schemas.microsoft.com/office/drawing/2017/decorative" val="1"/>
-                </a:ext>
-              </a:extLst>
-            </p:cNvPr>
-            <p:cNvSpPr/>
-            <p:nvPr>
-              <p:extLst>
-                <p:ext uri="{386F3935-93C4-4BCD-93E2-E3B085C9AB24}">
-                  <p16:designElem xmlns:p16="http://schemas.microsoft.com/office/powerpoint/2015/main" val="1"/>
-                </p:ext>
-              </p:extLst>
-            </p:nvPr>
-          </p:nvSpPr>
-          <p:spPr>
-            <a:xfrm>
-              <a:off x="8932333" y="3048000"/>
-              <a:ext cx="3259667" cy="3810000"/>
-            </a:xfrm>
-            <a:prstGeom prst="triangle">
-              <a:avLst>
-                <a:gd name="adj" fmla="val 100000"/>
-              </a:avLst>
-            </a:prstGeom>
-            <a:solidFill>
-              <a:schemeClr val="accent1">
-                <a:lumMod val="75000"/>
-                <a:alpha val="72000"/>
-              </a:schemeClr>
-            </a:solidFill>
-            <a:ln>
-              <a:noFill/>
-            </a:ln>
-            <a:effectLst/>
-          </p:spPr>
-          <p:style>
-            <a:lnRef idx="1">
-              <a:schemeClr val="accent1"/>
-            </a:lnRef>
-            <a:fillRef idx="3">
-              <a:schemeClr val="accent1"/>
-            </a:fillRef>
-            <a:effectRef idx="2">
-              <a:schemeClr val="accent1"/>
-            </a:effectRef>
-            <a:fontRef idx="minor">
-              <a:schemeClr val="lt1"/>
-            </a:fontRef>
-          </p:style>
-          <p:txBody>
-            <a:bodyPr/>
-            <a:lstStyle/>
-            <a:p>
-              <a:endParaRPr lang="en-US"/>
-            </a:p>
-          </p:txBody>
-        </p:sp>
-        <p:sp>
-          <p:nvSpPr>
-            <p:cNvPr id="17" name="Rectangle 27">
-              <a:extLst>
-                <a:ext uri="{FF2B5EF4-FFF2-40B4-BE49-F238E27FC236}">
-                  <a16:creationId xmlns:a16="http://schemas.microsoft.com/office/drawing/2014/main" id="{352A3EAD-426D-4399-B7E0-81D26F700399}"/>
-                </a:ext>
-                <a:ext uri="{C183D7F6-B498-43B3-948B-1728B52AA6E4}">
-                  <adec:decorative xmlns:adec="http://schemas.microsoft.com/office/drawing/2017/decorative" val="1"/>
-                </a:ext>
-              </a:extLst>
-            </p:cNvPr>
-            <p:cNvSpPr/>
-            <p:nvPr>
-              <p:extLst>
-                <p:ext uri="{386F3935-93C4-4BCD-93E2-E3B085C9AB24}">
-                  <p16:designElem xmlns:p16="http://schemas.microsoft.com/office/powerpoint/2015/main" val="1"/>
-                </p:ext>
-              </p:extLst>
-            </p:nvPr>
-          </p:nvSpPr>
-          <p:spPr>
-            <a:xfrm>
-              <a:off x="9334500" y="-8467"/>
-              <a:ext cx="2854326" cy="6866467"/>
-            </a:xfrm>
-            <a:custGeom>
-              <a:avLst/>
-              <a:gdLst/>
-              <a:ahLst/>
-              <a:cxnLst/>
-              <a:rect l="l" t="t" r="r" b="b"/>
-              <a:pathLst>
-                <a:path w="2858013" h="6866467">
-                  <a:moveTo>
-                    <a:pt x="0" y="0"/>
-                  </a:moveTo>
-                  <a:lnTo>
-                    <a:pt x="2858013" y="0"/>
-                  </a:lnTo>
-                  <a:lnTo>
-                    <a:pt x="2858013" y="6866467"/>
-                  </a:lnTo>
-                  <a:lnTo>
-                    <a:pt x="2473942" y="6866467"/>
-                  </a:lnTo>
-                  <a:lnTo>
-                    <a:pt x="0" y="0"/>
-                  </a:lnTo>
-                  <a:close/>
-                </a:path>
-              </a:pathLst>
-            </a:custGeom>
-            <a:solidFill>
-              <a:schemeClr val="accent1">
-                <a:lumMod val="75000"/>
-                <a:alpha val="60000"/>
-              </a:schemeClr>
-            </a:solidFill>
-            <a:ln>
-              <a:noFill/>
-            </a:ln>
-            <a:effectLst/>
-          </p:spPr>
-          <p:style>
-            <a:lnRef idx="1">
-              <a:schemeClr val="accent1"/>
-            </a:lnRef>
-            <a:fillRef idx="3">
-              <a:schemeClr val="accent1"/>
-            </a:fillRef>
-            <a:effectRef idx="2">
-              <a:schemeClr val="accent1"/>
-            </a:effectRef>
-            <a:fontRef idx="minor">
-              <a:schemeClr val="lt1"/>
-            </a:fontRef>
-          </p:style>
-          <p:txBody>
-            <a:bodyPr/>
-            <a:lstStyle/>
-            <a:p>
-              <a:endParaRPr lang="en-US"/>
-            </a:p>
-          </p:txBody>
-        </p:sp>
-        <p:sp>
-          <p:nvSpPr>
-            <p:cNvPr id="18" name="Rectangle 28">
-              <a:extLst>
-                <a:ext uri="{FF2B5EF4-FFF2-40B4-BE49-F238E27FC236}">
-                  <a16:creationId xmlns:a16="http://schemas.microsoft.com/office/drawing/2014/main" id="{F842EF93-A507-4796-A726-0D0A9B751C38}"/>
-                </a:ext>
-                <a:ext uri="{C183D7F6-B498-43B3-948B-1728B52AA6E4}">
-                  <adec:decorative xmlns:adec="http://schemas.microsoft.com/office/drawing/2017/decorative" val="1"/>
-                </a:ext>
-              </a:extLst>
-            </p:cNvPr>
-            <p:cNvSpPr/>
-            <p:nvPr>
-              <p:extLst>
-                <p:ext uri="{386F3935-93C4-4BCD-93E2-E3B085C9AB24}">
-                  <p16:designElem xmlns:p16="http://schemas.microsoft.com/office/powerpoint/2015/main" val="1"/>
-                </p:ext>
-              </p:extLst>
-            </p:nvPr>
-          </p:nvSpPr>
-          <p:spPr>
-            <a:xfrm>
-              <a:off x="10898730" y="-8467"/>
-              <a:ext cx="1290094" cy="6866467"/>
-            </a:xfrm>
-            <a:custGeom>
-              <a:avLst/>
-              <a:gdLst/>
-              <a:ahLst/>
-              <a:cxnLst/>
-              <a:rect l="l" t="t" r="r" b="b"/>
-              <a:pathLst>
-                <a:path w="1290094" h="6858000">
-                  <a:moveTo>
-                    <a:pt x="1019735" y="0"/>
-                  </a:moveTo>
-                  <a:lnTo>
-                    <a:pt x="1290094" y="0"/>
-                  </a:lnTo>
-                  <a:lnTo>
-                    <a:pt x="1290094" y="6858000"/>
-                  </a:lnTo>
-                  <a:lnTo>
-                    <a:pt x="0" y="6858000"/>
-                  </a:lnTo>
-                  <a:lnTo>
-                    <a:pt x="1019735" y="0"/>
-                  </a:lnTo>
-                  <a:close/>
-                </a:path>
-              </a:pathLst>
-            </a:custGeom>
-            <a:solidFill>
-              <a:schemeClr val="accent1">
-                <a:lumMod val="60000"/>
-                <a:lumOff val="40000"/>
-                <a:alpha val="70000"/>
-              </a:schemeClr>
-            </a:solidFill>
-            <a:ln>
-              <a:noFill/>
-            </a:ln>
-            <a:effectLst/>
-          </p:spPr>
-          <p:style>
-            <a:lnRef idx="1">
-              <a:schemeClr val="accent1"/>
-            </a:lnRef>
-            <a:fillRef idx="3">
-              <a:schemeClr val="accent1"/>
-            </a:fillRef>
-            <a:effectRef idx="2">
-              <a:schemeClr val="accent1"/>
-            </a:effectRef>
-            <a:fontRef idx="minor">
-              <a:schemeClr val="lt1"/>
-            </a:fontRef>
-          </p:style>
-          <p:txBody>
-            <a:bodyPr/>
-            <a:lstStyle/>
-            <a:p>
-              <a:endParaRPr lang="en-US"/>
-            </a:p>
-          </p:txBody>
-        </p:sp>
-        <p:sp>
-          <p:nvSpPr>
-            <p:cNvPr id="19" name="Rectangle 29">
-              <a:extLst>
-                <a:ext uri="{FF2B5EF4-FFF2-40B4-BE49-F238E27FC236}">
-                  <a16:creationId xmlns:a16="http://schemas.microsoft.com/office/drawing/2014/main" id="{24F1410B-DBCE-471A-97C3-B96C0A7BBCE2}"/>
-                </a:ext>
-                <a:ext uri="{C183D7F6-B498-43B3-948B-1728B52AA6E4}">
-                  <adec:decorative xmlns:adec="http://schemas.microsoft.com/office/drawing/2017/decorative" val="1"/>
-                </a:ext>
-              </a:extLst>
-            </p:cNvPr>
-            <p:cNvSpPr/>
-            <p:nvPr>
-              <p:extLst>
-                <p:ext uri="{386F3935-93C4-4BCD-93E2-E3B085C9AB24}">
-                  <p16:designElem xmlns:p16="http://schemas.microsoft.com/office/powerpoint/2015/main" val="1"/>
-                </p:ext>
-              </p:extLst>
-            </p:nvPr>
-          </p:nvSpPr>
-          <p:spPr>
-            <a:xfrm>
-              <a:off x="10938999" y="-8467"/>
-              <a:ext cx="1249825" cy="6866467"/>
-            </a:xfrm>
-            <a:custGeom>
-              <a:avLst/>
-              <a:gdLst/>
-              <a:ahLst/>
-              <a:cxnLst/>
-              <a:rect l="l" t="t" r="r" b="b"/>
-              <a:pathLst>
-                <a:path w="1249825" h="6858000">
-                  <a:moveTo>
-                    <a:pt x="0" y="0"/>
-                  </a:moveTo>
-                  <a:lnTo>
-                    <a:pt x="1249825" y="0"/>
-                  </a:lnTo>
-                  <a:lnTo>
-                    <a:pt x="1249825" y="6858000"/>
-                  </a:lnTo>
-                  <a:lnTo>
-                    <a:pt x="1109382" y="6858000"/>
-                  </a:lnTo>
-                  <a:lnTo>
-                    <a:pt x="0" y="0"/>
-                  </a:lnTo>
-                  <a:close/>
-                </a:path>
-              </a:pathLst>
-            </a:custGeom>
-            <a:solidFill>
-              <a:schemeClr val="accent1">
-                <a:alpha val="65000"/>
-              </a:schemeClr>
-            </a:solidFill>
-            <a:ln>
-              <a:noFill/>
-            </a:ln>
-            <a:effectLst/>
-          </p:spPr>
-          <p:style>
-            <a:lnRef idx="1">
-              <a:schemeClr val="accent1"/>
-            </a:lnRef>
-            <a:fillRef idx="3">
-              <a:schemeClr val="accent1"/>
-            </a:fillRef>
-            <a:effectRef idx="2">
-              <a:schemeClr val="accent1"/>
-            </a:effectRef>
-            <a:fontRef idx="minor">
-              <a:schemeClr val="lt1"/>
-            </a:fontRef>
-          </p:style>
-          <p:txBody>
-            <a:bodyPr/>
-            <a:lstStyle/>
-            <a:p>
-              <a:endParaRPr lang="en-US"/>
-            </a:p>
-          </p:txBody>
-        </p:sp>
-        <p:sp>
-          <p:nvSpPr>
-            <p:cNvPr id="20" name="Isosceles Triangle 19">
-              <a:extLst>
-                <a:ext uri="{FF2B5EF4-FFF2-40B4-BE49-F238E27FC236}">
-                  <a16:creationId xmlns:a16="http://schemas.microsoft.com/office/drawing/2014/main" id="{0BBC8502-8D68-4CE4-B690-2EBB6BCCDD1C}"/>
-                </a:ext>
-                <a:ext uri="{C183D7F6-B498-43B3-948B-1728B52AA6E4}">
-                  <adec:decorative xmlns:adec="http://schemas.microsoft.com/office/drawing/2017/decorative" val="1"/>
-                </a:ext>
-              </a:extLst>
-            </p:cNvPr>
-            <p:cNvSpPr/>
-            <p:nvPr>
-              <p:extLst>
-                <p:ext uri="{386F3935-93C4-4BCD-93E2-E3B085C9AB24}">
-                  <p16:designElem xmlns:p16="http://schemas.microsoft.com/office/powerpoint/2015/main" val="1"/>
-                </p:ext>
-              </p:extLst>
-            </p:nvPr>
-          </p:nvSpPr>
-          <p:spPr>
-            <a:xfrm>
-              <a:off x="10371666" y="3589867"/>
-              <a:ext cx="1817159" cy="3268133"/>
-            </a:xfrm>
-            <a:prstGeom prst="triangle">
-              <a:avLst>
-                <a:gd name="adj" fmla="val 100000"/>
-              </a:avLst>
-            </a:prstGeom>
-            <a:solidFill>
-              <a:schemeClr val="accent1">
-                <a:alpha val="80000"/>
-              </a:schemeClr>
-            </a:solidFill>
-            <a:ln>
-              <a:noFill/>
-            </a:ln>
-            <a:effectLst/>
-          </p:spPr>
-          <p:style>
-            <a:lnRef idx="1">
-              <a:schemeClr val="accent1"/>
-            </a:lnRef>
-            <a:fillRef idx="3">
-              <a:schemeClr val="accent1"/>
-            </a:fillRef>
-            <a:effectRef idx="2">
-              <a:schemeClr val="accent1"/>
-            </a:effectRef>
-            <a:fontRef idx="minor">
-              <a:schemeClr val="lt1"/>
-            </a:fontRef>
-          </p:style>
-          <p:txBody>
-            <a:bodyPr/>
-            <a:lstStyle/>
-            <a:p>
-              <a:endParaRPr lang="en-US"/>
-            </a:p>
-          </p:txBody>
-        </p:sp>
-      </p:grpSp>
       <p:sp>
         <p:nvSpPr>
           <p:cNvPr id="2" name="Title 1">
@@ -20477,66 +20181,6 @@
               <a:rPr lang="en-US" sz="3800"/>
               <a:t>What Counts as Success Today</a:t>
             </a:r>
-          </a:p>
-        </p:txBody>
-      </p:sp>
-      <p:sp>
-        <p:nvSpPr>
-          <p:cNvPr id="22" name="Rectangle 21">
-            <a:extLst>
-              <a:ext uri="{FF2B5EF4-FFF2-40B4-BE49-F238E27FC236}">
-                <a16:creationId xmlns:a16="http://schemas.microsoft.com/office/drawing/2014/main" id="{DE77CD7A-FE9E-475D-BF9C-78183B0B1BAC}"/>
-              </a:ext>
-              <a:ext uri="{C183D7F6-B498-43B3-948B-1728B52AA6E4}">
-                <adec:decorative xmlns:adec="http://schemas.microsoft.com/office/drawing/2017/decorative" val="1"/>
-              </a:ext>
-            </a:extLst>
-          </p:cNvPr>
-          <p:cNvSpPr>
-            <a:spLocks noGrp="1" noRot="1" noChangeAspect="1" noMove="1" noResize="1" noEditPoints="1" noAdjustHandles="1" noChangeArrowheads="1" noChangeShapeType="1" noTextEdit="1"/>
-          </p:cNvSpPr>
-          <p:nvPr>
-            <p:extLst>
-              <p:ext uri="{386F3935-93C4-4BCD-93E2-E3B085C9AB24}">
-                <p16:designElem xmlns:p16="http://schemas.microsoft.com/office/powerpoint/2015/main" val="1"/>
-              </p:ext>
-            </p:extLst>
-          </p:nvPr>
-        </p:nvSpPr>
-        <p:spPr>
-          <a:xfrm>
-            <a:off x="4306968" y="0"/>
-            <a:ext cx="4837032" cy="6858000"/>
-          </a:xfrm>
-          <a:prstGeom prst="rect">
-            <a:avLst/>
-          </a:prstGeom>
-          <a:ln>
-            <a:noFill/>
-          </a:ln>
-        </p:spPr>
-        <p:style>
-          <a:lnRef idx="2">
-            <a:schemeClr val="accent1">
-              <a:shade val="50000"/>
-            </a:schemeClr>
-          </a:lnRef>
-          <a:fillRef idx="1">
-            <a:schemeClr val="accent1"/>
-          </a:fillRef>
-          <a:effectRef idx="0">
-            <a:schemeClr val="accent1"/>
-          </a:effectRef>
-          <a:fontRef idx="minor">
-            <a:schemeClr val="lt1"/>
-          </a:fontRef>
-        </p:style>
-        <p:txBody>
-          <a:bodyPr rtlCol="0" anchor="ctr"/>
-          <a:lstStyle/>
-          <a:p>
-            <a:pPr algn="ctr"/>
-            <a:endParaRPr lang="en-US"/>
           </a:p>
         </p:txBody>
       </p:sp>
@@ -20554,11 +20198,6 @@
           </p:cNvGraphicFramePr>
           <p:nvPr>
             <p:ph idx="1"/>
-            <p:extLst>
-              <p:ext uri="{D42A27DB-BD31-4B8C-83A1-F6EECF244321}">
-                <p14:modId xmlns:p14="http://schemas.microsoft.com/office/powerpoint/2010/main" val="727880109"/>
-              </p:ext>
-            </p:extLst>
           </p:nvPr>
         </p:nvGraphicFramePr>
         <p:xfrm>
@@ -20574,7 +20213,7 @@
     </p:spTree>
     <p:extLst>
       <p:ext uri="{BB962C8B-B14F-4D97-AF65-F5344CB8AC3E}">
-        <p14:creationId xmlns:p14="http://schemas.microsoft.com/office/powerpoint/2010/main" val="4082066743"/>
+        <p14:creationId xmlns:p14="http://schemas.microsoft.com/office/powerpoint/2010/main" val="2841456028"/>
       </p:ext>
     </p:extLst>
   </p:cSld>
@@ -20648,6 +20287,9 @@
             <a:extLst>
               <a:ext uri="{FF2B5EF4-FFF2-40B4-BE49-F238E27FC236}">
                 <a16:creationId xmlns:a16="http://schemas.microsoft.com/office/drawing/2014/main" id="{6A1B117B-7548-ADF5-1699-217128A6553A}"/>
+              </a:ext>
+              <a:ext uri="{C183D7F6-B498-43B3-948B-1728B52AA6E4}">
+                <adec:decorative xmlns:adec="http://schemas.microsoft.com/office/drawing/2017/decorative" val="1"/>
               </a:ext>
             </a:extLst>
           </p:cNvPr>

</xml_diff>

<commit_message>
117 - Week 7 Lecture Slides
</commit_message>
<xml_diff>
--- a/10-152-117_Python_Programming/Slide_Decks/W0ND0N_Lecture_Slides.pptx
+++ b/10-152-117_Python_Programming/Slide_Decks/W0ND0N_Lecture_Slides.pptx
@@ -3315,7 +3315,7 @@
           <a:p>
             <a:fld id="{64943E5A-6629-4B53-8BAD-0FC37077EB14}" type="datetimeFigureOut">
               <a:rPr lang="en-US" smtClean="0"/>
-              <a:t>6/18/2026</a:t>
+              <a:t>6/20/2026</a:t>
             </a:fld>
             <a:endParaRPr lang="en-US"/>
           </a:p>
@@ -3492,7 +3492,7 @@
           <a:p>
             <a:fld id="{E3382475-516A-409A-944E-F435F3DFCCF2}" type="datetimeFigureOut">
               <a:rPr lang="en-US" smtClean="0"/>
-              <a:t>6/18/2026</a:t>
+              <a:t>6/20/2026</a:t>
             </a:fld>
             <a:endParaRPr lang="en-US"/>
           </a:p>
@@ -6565,7 +6565,7 @@
           <a:p>
             <a:fld id="{5BCAD085-E8A6-8845-BD4E-CB4CCA059FC4}" type="datetimeFigureOut">
               <a:rPr lang="en-US" smtClean="0"/>
-              <a:t>6/18/2026</a:t>
+              <a:t>6/20/2026</a:t>
             </a:fld>
             <a:endParaRPr lang="en-US"/>
           </a:p>
@@ -6846,7 +6846,7 @@
           <a:p>
             <a:fld id="{5BCAD085-E8A6-8845-BD4E-CB4CCA059FC4}" type="datetimeFigureOut">
               <a:rPr lang="en-US" smtClean="0"/>
-              <a:t>6/18/2026</a:t>
+              <a:t>6/20/2026</a:t>
             </a:fld>
             <a:endParaRPr lang="en-US"/>
           </a:p>
@@ -7190,7 +7190,7 @@
           <a:p>
             <a:fld id="{5BCAD085-E8A6-8845-BD4E-CB4CCA059FC4}" type="datetimeFigureOut">
               <a:rPr lang="en-US" smtClean="0"/>
-              <a:t>6/18/2026</a:t>
+              <a:t>6/20/2026</a:t>
             </a:fld>
             <a:endParaRPr lang="en-US"/>
           </a:p>
@@ -7547,7 +7547,7 @@
           <a:p>
             <a:fld id="{5BCAD085-E8A6-8845-BD4E-CB4CCA059FC4}" type="datetimeFigureOut">
               <a:rPr lang="en-US" smtClean="0"/>
-              <a:t>6/18/2026</a:t>
+              <a:t>6/20/2026</a:t>
             </a:fld>
             <a:endParaRPr lang="en-US"/>
           </a:p>
@@ -7891,7 +7891,7 @@
           <a:p>
             <a:fld id="{5BCAD085-E8A6-8845-BD4E-CB4CCA059FC4}" type="datetimeFigureOut">
               <a:rPr lang="en-US" smtClean="0"/>
-              <a:t>6/18/2026</a:t>
+              <a:t>6/20/2026</a:t>
             </a:fld>
             <a:endParaRPr lang="en-US"/>
           </a:p>
@@ -8308,7 +8308,7 @@
           <a:p>
             <a:fld id="{5BCAD085-E8A6-8845-BD4E-CB4CCA059FC4}" type="datetimeFigureOut">
               <a:rPr lang="en-US" smtClean="0"/>
-              <a:t>6/18/2026</a:t>
+              <a:t>6/20/2026</a:t>
             </a:fld>
             <a:endParaRPr lang="en-US"/>
           </a:p>
@@ -8508,7 +8508,7 @@
           <a:p>
             <a:fld id="{5BCAD085-E8A6-8845-BD4E-CB4CCA059FC4}" type="datetimeFigureOut">
               <a:rPr lang="en-US" smtClean="0"/>
-              <a:t>6/18/2026</a:t>
+              <a:t>6/20/2026</a:t>
             </a:fld>
             <a:endParaRPr lang="en-US"/>
           </a:p>
@@ -8718,7 +8718,7 @@
           <a:p>
             <a:fld id="{5BCAD085-E8A6-8845-BD4E-CB4CCA059FC4}" type="datetimeFigureOut">
               <a:rPr lang="en-US" smtClean="0"/>
-              <a:t>6/18/2026</a:t>
+              <a:t>6/20/2026</a:t>
             </a:fld>
             <a:endParaRPr lang="en-US"/>
           </a:p>
@@ -8894,7 +8894,7 @@
           <a:p>
             <a:fld id="{5BCAD085-E8A6-8845-BD4E-CB4CCA059FC4}" type="datetimeFigureOut">
               <a:rPr lang="en-US" smtClean="0"/>
-              <a:t>6/18/2026</a:t>
+              <a:t>6/20/2026</a:t>
             </a:fld>
             <a:endParaRPr lang="en-US"/>
           </a:p>
@@ -9171,7 +9171,7 @@
           <a:p>
             <a:fld id="{5BCAD085-E8A6-8845-BD4E-CB4CCA059FC4}" type="datetimeFigureOut">
               <a:rPr lang="en-US" smtClean="0"/>
-              <a:t>6/18/2026</a:t>
+              <a:t>6/20/2026</a:t>
             </a:fld>
             <a:endParaRPr lang="en-US"/>
           </a:p>
@@ -9498,7 +9498,7 @@
           <a:p>
             <a:fld id="{5BCAD085-E8A6-8845-BD4E-CB4CCA059FC4}" type="datetimeFigureOut">
               <a:rPr lang="en-US" smtClean="0"/>
-              <a:t>6/18/2026</a:t>
+              <a:t>6/20/2026</a:t>
             </a:fld>
             <a:endParaRPr lang="en-US"/>
           </a:p>
@@ -9907,7 +9907,7 @@
           <a:p>
             <a:fld id="{5BCAD085-E8A6-8845-BD4E-CB4CCA059FC4}" type="datetimeFigureOut">
               <a:rPr lang="en-US" smtClean="0"/>
-              <a:t>6/18/2026</a:t>
+              <a:t>6/20/2026</a:t>
             </a:fld>
             <a:endParaRPr lang="en-US"/>
           </a:p>
@@ -10060,7 +10060,7 @@
           <a:p>
             <a:fld id="{5BCAD085-E8A6-8845-BD4E-CB4CCA059FC4}" type="datetimeFigureOut">
               <a:rPr lang="en-US" smtClean="0"/>
-              <a:t>6/18/2026</a:t>
+              <a:t>6/20/2026</a:t>
             </a:fld>
             <a:endParaRPr lang="en-US"/>
           </a:p>
@@ -10155,7 +10155,7 @@
           <a:p>
             <a:fld id="{5BCAD085-E8A6-8845-BD4E-CB4CCA059FC4}" type="datetimeFigureOut">
               <a:rPr lang="en-US" smtClean="0"/>
-              <a:t>6/18/2026</a:t>
+              <a:t>6/20/2026</a:t>
             </a:fld>
             <a:endParaRPr lang="en-US"/>
           </a:p>
@@ -10440,7 +10440,7 @@
           <a:p>
             <a:fld id="{5BCAD085-E8A6-8845-BD4E-CB4CCA059FC4}" type="datetimeFigureOut">
               <a:rPr lang="en-US" smtClean="0"/>
-              <a:t>6/18/2026</a:t>
+              <a:t>6/20/2026</a:t>
             </a:fld>
             <a:endParaRPr lang="en-US"/>
           </a:p>
@@ -10733,7 +10733,7 @@
           <a:p>
             <a:fld id="{5BCAD085-E8A6-8845-BD4E-CB4CCA059FC4}" type="datetimeFigureOut">
               <a:rPr lang="en-US" smtClean="0"/>
-              <a:t>6/18/2026</a:t>
+              <a:t>6/20/2026</a:t>
             </a:fld>
             <a:endParaRPr lang="en-US"/>
           </a:p>
@@ -11635,7 +11635,7 @@
           <a:p>
             <a:fld id="{5BCAD085-E8A6-8845-BD4E-CB4CCA059FC4}" type="datetimeFigureOut">
               <a:rPr lang="en-US" smtClean="0"/>
-              <a:t>6/18/2026</a:t>
+              <a:t>6/20/2026</a:t>
             </a:fld>
             <a:endParaRPr lang="en-US"/>
           </a:p>

</xml_diff>